<commit_message>
Add Cross-Encoder logic, update presentation, and finalize system
</commit_message>
<xml_diff>
--- a/Agentic_RAG .pptx
+++ b/Agentic_RAG .pptx
@@ -5016,6 +5016,12 @@
               <a:t>Cross-Encoder strictly caps LLM input context to &lt;2,000 tokens.</a:t>
             </a:r>
           </a:p>
+          <a:p>
+            <a:pPr/>
+            <a:r>
+              <a:t>Dynamic Search Depth: k expands on retries to prevent placebo loops.</a:t>
+            </a:r>
+          </a:p>
         </p:txBody>
       </p:sp>
       <p:sp>

</xml_diff>

<commit_message>
updated presentation with improved formatting and new sections
</commit_message>
<xml_diff>
--- a/Agentic_RAG .pptx
+++ b/Agentic_RAG .pptx
@@ -22,6 +22,7 @@
     <p:sldId id="267" r:id="rId19"/>
     <p:sldId id="268" r:id="rId20"/>
     <p:sldId id="269" r:id="rId21"/>
+    <p:sldId id="270" r:id="rId22"/>
   </p:sldIdLst>
   <p:sldSz cx="9144000" cy="6858000"/>
   <p:notesSz cx="6858000" cy="9144000"/>
@@ -79,10 +80,10 @@
         <a:latin typeface="+mj-lt"/>
         <a:ea typeface="+mj-ea"/>
         <a:cs typeface="+mj-cs"/>
-        <a:sym typeface="Calibri"/>
+        <a:sym typeface="Helvetica"/>
       </a:defRPr>
     </a:lvl1pPr>
-    <a:lvl2pPr marL="0" marR="0" indent="457200" algn="l" defTabSz="457200" rtl="0" fontAlgn="auto" latinLnBrk="0" hangingPunct="0">
+    <a:lvl2pPr marL="0" marR="0" indent="0" algn="l" defTabSz="457200" rtl="0" fontAlgn="auto" latinLnBrk="0" hangingPunct="0">
       <a:lnSpc>
         <a:spcPct val="100000"/>
       </a:lnSpc>
@@ -109,10 +110,10 @@
         <a:latin typeface="+mj-lt"/>
         <a:ea typeface="+mj-ea"/>
         <a:cs typeface="+mj-cs"/>
-        <a:sym typeface="Calibri"/>
+        <a:sym typeface="Helvetica"/>
       </a:defRPr>
     </a:lvl2pPr>
-    <a:lvl3pPr marL="0" marR="0" indent="914400" algn="l" defTabSz="457200" rtl="0" fontAlgn="auto" latinLnBrk="0" hangingPunct="0">
+    <a:lvl3pPr marL="0" marR="0" indent="0" algn="l" defTabSz="457200" rtl="0" fontAlgn="auto" latinLnBrk="0" hangingPunct="0">
       <a:lnSpc>
         <a:spcPct val="100000"/>
       </a:lnSpc>
@@ -139,10 +140,10 @@
         <a:latin typeface="+mj-lt"/>
         <a:ea typeface="+mj-ea"/>
         <a:cs typeface="+mj-cs"/>
-        <a:sym typeface="Calibri"/>
+        <a:sym typeface="Helvetica"/>
       </a:defRPr>
     </a:lvl3pPr>
-    <a:lvl4pPr marL="0" marR="0" indent="1371600" algn="l" defTabSz="457200" rtl="0" fontAlgn="auto" latinLnBrk="0" hangingPunct="0">
+    <a:lvl4pPr marL="0" marR="0" indent="0" algn="l" defTabSz="457200" rtl="0" fontAlgn="auto" latinLnBrk="0" hangingPunct="0">
       <a:lnSpc>
         <a:spcPct val="100000"/>
       </a:lnSpc>
@@ -169,10 +170,10 @@
         <a:latin typeface="+mj-lt"/>
         <a:ea typeface="+mj-ea"/>
         <a:cs typeface="+mj-cs"/>
-        <a:sym typeface="Calibri"/>
+        <a:sym typeface="Helvetica"/>
       </a:defRPr>
     </a:lvl4pPr>
-    <a:lvl5pPr marL="0" marR="0" indent="1828800" algn="l" defTabSz="457200" rtl="0" fontAlgn="auto" latinLnBrk="0" hangingPunct="0">
+    <a:lvl5pPr marL="0" marR="0" indent="0" algn="l" defTabSz="457200" rtl="0" fontAlgn="auto" latinLnBrk="0" hangingPunct="0">
       <a:lnSpc>
         <a:spcPct val="100000"/>
       </a:lnSpc>
@@ -199,10 +200,10 @@
         <a:latin typeface="+mj-lt"/>
         <a:ea typeface="+mj-ea"/>
         <a:cs typeface="+mj-cs"/>
-        <a:sym typeface="Calibri"/>
+        <a:sym typeface="Helvetica"/>
       </a:defRPr>
     </a:lvl5pPr>
-    <a:lvl6pPr marL="0" marR="0" indent="2286000" algn="l" defTabSz="457200" rtl="0" fontAlgn="auto" latinLnBrk="0" hangingPunct="0">
+    <a:lvl6pPr marL="0" marR="0" indent="0" algn="l" defTabSz="457200" rtl="0" fontAlgn="auto" latinLnBrk="0" hangingPunct="0">
       <a:lnSpc>
         <a:spcPct val="100000"/>
       </a:lnSpc>
@@ -229,10 +230,10 @@
         <a:latin typeface="+mj-lt"/>
         <a:ea typeface="+mj-ea"/>
         <a:cs typeface="+mj-cs"/>
-        <a:sym typeface="Calibri"/>
+        <a:sym typeface="Helvetica"/>
       </a:defRPr>
     </a:lvl6pPr>
-    <a:lvl7pPr marL="0" marR="0" indent="2743200" algn="l" defTabSz="457200" rtl="0" fontAlgn="auto" latinLnBrk="0" hangingPunct="0">
+    <a:lvl7pPr marL="0" marR="0" indent="0" algn="l" defTabSz="457200" rtl="0" fontAlgn="auto" latinLnBrk="0" hangingPunct="0">
       <a:lnSpc>
         <a:spcPct val="100000"/>
       </a:lnSpc>
@@ -259,10 +260,10 @@
         <a:latin typeface="+mj-lt"/>
         <a:ea typeface="+mj-ea"/>
         <a:cs typeface="+mj-cs"/>
-        <a:sym typeface="Calibri"/>
+        <a:sym typeface="Helvetica"/>
       </a:defRPr>
     </a:lvl7pPr>
-    <a:lvl8pPr marL="0" marR="0" indent="3200400" algn="l" defTabSz="457200" rtl="0" fontAlgn="auto" latinLnBrk="0" hangingPunct="0">
+    <a:lvl8pPr marL="0" marR="0" indent="0" algn="l" defTabSz="457200" rtl="0" fontAlgn="auto" latinLnBrk="0" hangingPunct="0">
       <a:lnSpc>
         <a:spcPct val="100000"/>
       </a:lnSpc>
@@ -289,10 +290,10 @@
         <a:latin typeface="+mj-lt"/>
         <a:ea typeface="+mj-ea"/>
         <a:cs typeface="+mj-cs"/>
-        <a:sym typeface="Calibri"/>
+        <a:sym typeface="Helvetica"/>
       </a:defRPr>
     </a:lvl8pPr>
-    <a:lvl9pPr marL="0" marR="0" indent="3657600" algn="l" defTabSz="457200" rtl="0" fontAlgn="auto" latinLnBrk="0" hangingPunct="0">
+    <a:lvl9pPr marL="0" marR="0" indent="0" algn="l" defTabSz="457200" rtl="0" fontAlgn="auto" latinLnBrk="0" hangingPunct="0">
       <a:lnSpc>
         <a:spcPct val="100000"/>
       </a:lnSpc>
@@ -319,7 +320,7 @@
         <a:latin typeface="+mj-lt"/>
         <a:ea typeface="+mj-ea"/>
         <a:cs typeface="+mj-cs"/>
-        <a:sym typeface="Calibri"/>
+        <a:sym typeface="Helvetica"/>
       </a:defRPr>
     </a:lvl9pPr>
   </p:defaultTextStyle>
@@ -403,73 +404,73 @@
   <p:notesStyle>
     <a:lvl1pPr defTabSz="457200" latinLnBrk="0">
       <a:defRPr sz="1200">
-        <a:latin typeface="+mj-lt"/>
-        <a:ea typeface="+mj-ea"/>
-        <a:cs typeface="+mj-cs"/>
+        <a:latin typeface="+mn-lt"/>
+        <a:ea typeface="+mn-ea"/>
+        <a:cs typeface="+mn-cs"/>
         <a:sym typeface="Calibri"/>
       </a:defRPr>
     </a:lvl1pPr>
     <a:lvl2pPr indent="228600" defTabSz="457200" latinLnBrk="0">
       <a:defRPr sz="1200">
-        <a:latin typeface="+mj-lt"/>
-        <a:ea typeface="+mj-ea"/>
-        <a:cs typeface="+mj-cs"/>
+        <a:latin typeface="+mn-lt"/>
+        <a:ea typeface="+mn-ea"/>
+        <a:cs typeface="+mn-cs"/>
         <a:sym typeface="Calibri"/>
       </a:defRPr>
     </a:lvl2pPr>
     <a:lvl3pPr indent="457200" defTabSz="457200" latinLnBrk="0">
       <a:defRPr sz="1200">
-        <a:latin typeface="+mj-lt"/>
-        <a:ea typeface="+mj-ea"/>
-        <a:cs typeface="+mj-cs"/>
+        <a:latin typeface="+mn-lt"/>
+        <a:ea typeface="+mn-ea"/>
+        <a:cs typeface="+mn-cs"/>
         <a:sym typeface="Calibri"/>
       </a:defRPr>
     </a:lvl3pPr>
     <a:lvl4pPr indent="685800" defTabSz="457200" latinLnBrk="0">
       <a:defRPr sz="1200">
-        <a:latin typeface="+mj-lt"/>
-        <a:ea typeface="+mj-ea"/>
-        <a:cs typeface="+mj-cs"/>
+        <a:latin typeface="+mn-lt"/>
+        <a:ea typeface="+mn-ea"/>
+        <a:cs typeface="+mn-cs"/>
         <a:sym typeface="Calibri"/>
       </a:defRPr>
     </a:lvl4pPr>
     <a:lvl5pPr indent="914400" defTabSz="457200" latinLnBrk="0">
       <a:defRPr sz="1200">
-        <a:latin typeface="+mj-lt"/>
-        <a:ea typeface="+mj-ea"/>
-        <a:cs typeface="+mj-cs"/>
+        <a:latin typeface="+mn-lt"/>
+        <a:ea typeface="+mn-ea"/>
+        <a:cs typeface="+mn-cs"/>
         <a:sym typeface="Calibri"/>
       </a:defRPr>
     </a:lvl5pPr>
     <a:lvl6pPr indent="1143000" defTabSz="457200" latinLnBrk="0">
       <a:defRPr sz="1200">
-        <a:latin typeface="+mj-lt"/>
-        <a:ea typeface="+mj-ea"/>
-        <a:cs typeface="+mj-cs"/>
+        <a:latin typeface="+mn-lt"/>
+        <a:ea typeface="+mn-ea"/>
+        <a:cs typeface="+mn-cs"/>
         <a:sym typeface="Calibri"/>
       </a:defRPr>
     </a:lvl6pPr>
     <a:lvl7pPr indent="1371600" defTabSz="457200" latinLnBrk="0">
       <a:defRPr sz="1200">
-        <a:latin typeface="+mj-lt"/>
-        <a:ea typeface="+mj-ea"/>
-        <a:cs typeface="+mj-cs"/>
+        <a:latin typeface="+mn-lt"/>
+        <a:ea typeface="+mn-ea"/>
+        <a:cs typeface="+mn-cs"/>
         <a:sym typeface="Calibri"/>
       </a:defRPr>
     </a:lvl7pPr>
     <a:lvl8pPr indent="1600200" defTabSz="457200" latinLnBrk="0">
       <a:defRPr sz="1200">
-        <a:latin typeface="+mj-lt"/>
-        <a:ea typeface="+mj-ea"/>
-        <a:cs typeface="+mj-cs"/>
+        <a:latin typeface="+mn-lt"/>
+        <a:ea typeface="+mn-ea"/>
+        <a:cs typeface="+mn-cs"/>
         <a:sym typeface="Calibri"/>
       </a:defRPr>
     </a:lvl8pPr>
     <a:lvl9pPr indent="1828800" defTabSz="457200" latinLnBrk="0">
       <a:defRPr sz="1200">
-        <a:latin typeface="+mj-lt"/>
-        <a:ea typeface="+mj-ea"/>
-        <a:cs typeface="+mj-cs"/>
+        <a:latin typeface="+mn-lt"/>
+        <a:ea typeface="+mn-ea"/>
+        <a:cs typeface="+mn-cs"/>
         <a:sym typeface="Calibri"/>
       </a:defRPr>
     </a:lvl9pPr>
@@ -552,7 +553,7 @@
                 </a:solidFill>
               </a:defRPr>
             </a:lvl1pPr>
-            <a:lvl2pPr marL="0" indent="457200" algn="ctr">
+            <a:lvl2pPr marL="0" indent="0" algn="ctr">
               <a:buSzTx/>
               <a:buFontTx/>
               <a:buNone/>
@@ -562,7 +563,7 @@
                 </a:solidFill>
               </a:defRPr>
             </a:lvl2pPr>
-            <a:lvl3pPr marL="0" indent="914400" algn="ctr">
+            <a:lvl3pPr marL="0" indent="0" algn="ctr">
               <a:buSzTx/>
               <a:buFontTx/>
               <a:buNone/>
@@ -572,7 +573,7 @@
                 </a:solidFill>
               </a:defRPr>
             </a:lvl3pPr>
-            <a:lvl4pPr marL="0" indent="1371600" algn="ctr">
+            <a:lvl4pPr marL="0" indent="0" algn="ctr">
               <a:buSzTx/>
               <a:buFontTx/>
               <a:buNone/>
@@ -582,7 +583,7 @@
                 </a:solidFill>
               </a:defRPr>
             </a:lvl4pPr>
-            <a:lvl5pPr marL="0" indent="1828800" algn="ctr">
+            <a:lvl5pPr marL="0" indent="0" algn="ctr">
               <a:buSzTx/>
               <a:buFontTx/>
               <a:buNone/>
@@ -836,7 +837,7 @@
         <p:spPr>
           <a:xfrm>
             <a:off x="722312" y="2906713"/>
-            <a:ext cx="7772401" cy="1500188"/>
+            <a:ext cx="7772401" cy="1500189"/>
           </a:xfrm>
           <a:prstGeom prst="rect">
             <a:avLst/>
@@ -858,7 +859,7 @@
                 </a:solidFill>
               </a:defRPr>
             </a:lvl1pPr>
-            <a:lvl2pPr marL="0" indent="457200">
+            <a:lvl2pPr marL="0" indent="0">
               <a:spcBef>
                 <a:spcPts val="400"/>
               </a:spcBef>
@@ -871,7 +872,7 @@
                 </a:solidFill>
               </a:defRPr>
             </a:lvl2pPr>
-            <a:lvl3pPr marL="0" indent="914400">
+            <a:lvl3pPr marL="0" indent="0">
               <a:spcBef>
                 <a:spcPts val="400"/>
               </a:spcBef>
@@ -884,7 +885,7 @@
                 </a:solidFill>
               </a:defRPr>
             </a:lvl3pPr>
-            <a:lvl4pPr marL="0" indent="1371600">
+            <a:lvl4pPr marL="0" indent="0">
               <a:spcBef>
                 <a:spcPts val="400"/>
               </a:spcBef>
@@ -897,7 +898,7 @@
                 </a:solidFill>
               </a:defRPr>
             </a:lvl4pPr>
-            <a:lvl5pPr marL="0" indent="1828800">
+            <a:lvl5pPr marL="0" indent="0">
               <a:spcBef>
                 <a:spcPts val="400"/>
               </a:spcBef>
@@ -1047,7 +1048,7 @@
               </a:spcBef>
               <a:defRPr sz="2800"/>
             </a:lvl2pPr>
-            <a:lvl3pPr marL="1234439" indent="-320039">
+            <a:lvl3pPr marL="1234438" indent="-320038">
               <a:spcBef>
                 <a:spcPts val="600"/>
               </a:spcBef>
@@ -1199,7 +1200,7 @@
               <a:buNone/>
               <a:defRPr b="1" sz="2400"/>
             </a:lvl1pPr>
-            <a:lvl2pPr marL="0" indent="457200">
+            <a:lvl2pPr marL="0" indent="0">
               <a:spcBef>
                 <a:spcPts val="500"/>
               </a:spcBef>
@@ -1208,7 +1209,7 @@
               <a:buNone/>
               <a:defRPr b="1" sz="2400"/>
             </a:lvl2pPr>
-            <a:lvl3pPr marL="0" indent="914400">
+            <a:lvl3pPr marL="0" indent="0">
               <a:spcBef>
                 <a:spcPts val="500"/>
               </a:spcBef>
@@ -1217,7 +1218,7 @@
               <a:buNone/>
               <a:defRPr b="1" sz="2400"/>
             </a:lvl3pPr>
-            <a:lvl4pPr marL="0" indent="1371600">
+            <a:lvl4pPr marL="0" indent="0">
               <a:spcBef>
                 <a:spcPts val="500"/>
               </a:spcBef>
@@ -1226,7 +1227,7 @@
               <a:buNone/>
               <a:defRPr b="1" sz="2400"/>
             </a:lvl4pPr>
-            <a:lvl5pPr marL="0" indent="1828800">
+            <a:lvl5pPr marL="0" indent="0">
               <a:spcBef>
                 <a:spcPts val="500"/>
               </a:spcBef>
@@ -1278,8 +1279,8 @@
         </p:nvSpPr>
         <p:spPr>
           <a:xfrm>
-            <a:off x="4645025" y="1535112"/>
-            <a:ext cx="4041775" cy="639763"/>
+            <a:off x="4645025" y="1535111"/>
+            <a:ext cx="4041775" cy="639765"/>
           </a:xfrm>
           <a:prstGeom prst="rect">
             <a:avLst/>
@@ -1289,15 +1290,7 @@
           <a:bodyPr anchor="b"/>
           <a:lstStyle/>
           <a:p>
-            <a:pPr marL="0" indent="0">
-              <a:spcBef>
-                <a:spcPts val="500"/>
-              </a:spcBef>
-              <a:buSzTx/>
-              <a:buFontTx/>
-              <a:buNone/>
-              <a:defRPr b="1" sz="2400"/>
-            </a:pPr>
+            <a:pPr/>
           </a:p>
         </p:txBody>
       </p:sp>
@@ -1480,7 +1473,7 @@
         <p:spPr>
           <a:xfrm>
             <a:off x="457200" y="273050"/>
-            <a:ext cx="3008314" cy="1162050"/>
+            <a:ext cx="3008315" cy="1162050"/>
           </a:xfrm>
           <a:prstGeom prst="rect">
             <a:avLst/>
@@ -1563,8 +1556,8 @@
         </p:nvSpPr>
         <p:spPr>
           <a:xfrm>
-            <a:off x="457199" y="1435100"/>
-            <a:ext cx="3008315" cy="4691063"/>
+            <a:off x="457198" y="1435100"/>
+            <a:ext cx="3008316" cy="4691063"/>
           </a:xfrm>
           <a:prstGeom prst="rect">
             <a:avLst/>
@@ -1574,15 +1567,7 @@
           <a:bodyPr/>
           <a:lstStyle/>
           <a:p>
-            <a:pPr marL="0" indent="0">
-              <a:spcBef>
-                <a:spcPts val="300"/>
-              </a:spcBef>
-              <a:buSzTx/>
-              <a:buFontTx/>
-              <a:buNone/>
-              <a:defRPr sz="1400"/>
-            </a:pPr>
+            <a:pPr/>
           </a:p>
         </p:txBody>
       </p:sp>
@@ -1645,7 +1630,7 @@
         <p:spPr>
           <a:xfrm>
             <a:off x="1792288" y="4800600"/>
-            <a:ext cx="5486401" cy="566738"/>
+            <a:ext cx="5486402" cy="566738"/>
           </a:xfrm>
           <a:prstGeom prst="rect">
             <a:avLst/>
@@ -1677,14 +1662,14 @@
         <p:spPr>
           <a:xfrm>
             <a:off x="1792288" y="612775"/>
-            <a:ext cx="5486401" cy="4114800"/>
+            <a:ext cx="5486402" cy="4114800"/>
           </a:xfrm>
           <a:prstGeom prst="rect">
             <a:avLst/>
           </a:prstGeom>
         </p:spPr>
         <p:txBody>
-          <a:bodyPr lIns="91439" rIns="91439">
+          <a:bodyPr lIns="91439" tIns="45719" rIns="91439" bIns="45719">
             <a:noAutofit/>
           </a:bodyPr>
           <a:lstStyle/>
@@ -1704,7 +1689,7 @@
         <p:spPr>
           <a:xfrm>
             <a:off x="1792288" y="5367337"/>
-            <a:ext cx="5486401" cy="804863"/>
+            <a:ext cx="5486402" cy="804864"/>
           </a:xfrm>
           <a:prstGeom prst="rect">
             <a:avLst/>
@@ -1722,7 +1707,7 @@
               <a:buNone/>
               <a:defRPr sz="1400"/>
             </a:lvl1pPr>
-            <a:lvl2pPr marL="0" indent="457200">
+            <a:lvl2pPr marL="0" indent="0">
               <a:spcBef>
                 <a:spcPts val="300"/>
               </a:spcBef>
@@ -1731,7 +1716,7 @@
               <a:buNone/>
               <a:defRPr sz="1400"/>
             </a:lvl2pPr>
-            <a:lvl3pPr marL="0" indent="914400">
+            <a:lvl3pPr marL="0" indent="0">
               <a:spcBef>
                 <a:spcPts val="300"/>
               </a:spcBef>
@@ -1740,7 +1725,7 @@
               <a:buNone/>
               <a:defRPr sz="1400"/>
             </a:lvl3pPr>
-            <a:lvl4pPr marL="0" indent="1371600">
+            <a:lvl4pPr marL="0" indent="0">
               <a:spcBef>
                 <a:spcPts val="300"/>
               </a:spcBef>
@@ -1749,7 +1734,7 @@
               <a:buNone/>
               <a:defRPr sz="1400"/>
             </a:lvl4pPr>
-            <a:lvl5pPr marL="0" indent="1828800">
+            <a:lvl5pPr marL="0" indent="0">
               <a:spcBef>
                 <a:spcPts val="300"/>
               </a:spcBef>
@@ -1872,7 +1857,7 @@
           </a:extLst>
         </p:spPr>
         <p:txBody>
-          <a:bodyPr lIns="45719" rIns="45719" anchor="ctr">
+          <a:bodyPr lIns="45718" tIns="45718" rIns="45718" bIns="45718" anchor="ctr">
             <a:normAutofit fontScale="100000" lnSpcReduction="0"/>
           </a:bodyPr>
           <a:lstStyle/>
@@ -1910,7 +1895,7 @@
           </a:extLst>
         </p:spPr>
         <p:txBody>
-          <a:bodyPr lIns="45719" rIns="45719">
+          <a:bodyPr lIns="45718" tIns="45718" rIns="45718" bIns="45718">
             <a:normAutofit fontScale="100000" lnSpcReduction="0"/>
           </a:bodyPr>
           <a:lstStyle/>
@@ -1956,8 +1941,8 @@
         </p:nvSpPr>
         <p:spPr>
           <a:xfrm>
-            <a:off x="8428176" y="6414760"/>
-            <a:ext cx="258624" cy="248305"/>
+            <a:off x="8428178" y="6414761"/>
+            <a:ext cx="258623" cy="248303"/>
           </a:xfrm>
           <a:prstGeom prst="rect">
             <a:avLst/>
@@ -1967,7 +1952,7 @@
           </a:ln>
         </p:spPr>
         <p:txBody>
-          <a:bodyPr wrap="none" lIns="45719" rIns="45719" anchor="ctr">
+          <a:bodyPr wrap="none" lIns="45718" tIns="45718" rIns="45718" bIns="45718" anchor="ctr">
             <a:spAutoFit/>
           </a:bodyPr>
           <a:lstStyle>
@@ -1976,6 +1961,10 @@
                 <a:solidFill>
                   <a:srgbClr val="888888"/>
                 </a:solidFill>
+                <a:latin typeface="+mn-lt"/>
+                <a:ea typeface="+mn-ea"/>
+                <a:cs typeface="+mn-cs"/>
+                <a:sym typeface="Calibri"/>
               </a:defRPr>
             </a:lvl1pPr>
           </a:lstStyle>
@@ -2022,9 +2011,9 @@
             <a:srgbClr val="000000"/>
           </a:solidFill>
           <a:uFillTx/>
-          <a:latin typeface="+mj-lt"/>
-          <a:ea typeface="+mj-ea"/>
-          <a:cs typeface="+mj-cs"/>
+          <a:latin typeface="+mn-lt"/>
+          <a:ea typeface="+mn-ea"/>
+          <a:cs typeface="+mn-cs"/>
           <a:sym typeface="Calibri"/>
         </a:defRPr>
       </a:lvl1pPr>
@@ -2048,9 +2037,9 @@
             <a:srgbClr val="000000"/>
           </a:solidFill>
           <a:uFillTx/>
-          <a:latin typeface="+mj-lt"/>
-          <a:ea typeface="+mj-ea"/>
-          <a:cs typeface="+mj-cs"/>
+          <a:latin typeface="+mn-lt"/>
+          <a:ea typeface="+mn-ea"/>
+          <a:cs typeface="+mn-cs"/>
           <a:sym typeface="Calibri"/>
         </a:defRPr>
       </a:lvl2pPr>
@@ -2074,9 +2063,9 @@
             <a:srgbClr val="000000"/>
           </a:solidFill>
           <a:uFillTx/>
-          <a:latin typeface="+mj-lt"/>
-          <a:ea typeface="+mj-ea"/>
-          <a:cs typeface="+mj-cs"/>
+          <a:latin typeface="+mn-lt"/>
+          <a:ea typeface="+mn-ea"/>
+          <a:cs typeface="+mn-cs"/>
           <a:sym typeface="Calibri"/>
         </a:defRPr>
       </a:lvl3pPr>
@@ -2100,9 +2089,9 @@
             <a:srgbClr val="000000"/>
           </a:solidFill>
           <a:uFillTx/>
-          <a:latin typeface="+mj-lt"/>
-          <a:ea typeface="+mj-ea"/>
-          <a:cs typeface="+mj-cs"/>
+          <a:latin typeface="+mn-lt"/>
+          <a:ea typeface="+mn-ea"/>
+          <a:cs typeface="+mn-cs"/>
           <a:sym typeface="Calibri"/>
         </a:defRPr>
       </a:lvl4pPr>
@@ -2126,9 +2115,9 @@
             <a:srgbClr val="000000"/>
           </a:solidFill>
           <a:uFillTx/>
-          <a:latin typeface="+mj-lt"/>
-          <a:ea typeface="+mj-ea"/>
-          <a:cs typeface="+mj-cs"/>
+          <a:latin typeface="+mn-lt"/>
+          <a:ea typeface="+mn-ea"/>
+          <a:cs typeface="+mn-cs"/>
           <a:sym typeface="Calibri"/>
         </a:defRPr>
       </a:lvl5pPr>
@@ -2152,9 +2141,9 @@
             <a:srgbClr val="000000"/>
           </a:solidFill>
           <a:uFillTx/>
-          <a:latin typeface="+mj-lt"/>
-          <a:ea typeface="+mj-ea"/>
-          <a:cs typeface="+mj-cs"/>
+          <a:latin typeface="+mn-lt"/>
+          <a:ea typeface="+mn-ea"/>
+          <a:cs typeface="+mn-cs"/>
           <a:sym typeface="Calibri"/>
         </a:defRPr>
       </a:lvl6pPr>
@@ -2178,9 +2167,9 @@
             <a:srgbClr val="000000"/>
           </a:solidFill>
           <a:uFillTx/>
-          <a:latin typeface="+mj-lt"/>
-          <a:ea typeface="+mj-ea"/>
-          <a:cs typeface="+mj-cs"/>
+          <a:latin typeface="+mn-lt"/>
+          <a:ea typeface="+mn-ea"/>
+          <a:cs typeface="+mn-cs"/>
           <a:sym typeface="Calibri"/>
         </a:defRPr>
       </a:lvl7pPr>
@@ -2204,9 +2193,9 @@
             <a:srgbClr val="000000"/>
           </a:solidFill>
           <a:uFillTx/>
-          <a:latin typeface="+mj-lt"/>
-          <a:ea typeface="+mj-ea"/>
-          <a:cs typeface="+mj-cs"/>
+          <a:latin typeface="+mn-lt"/>
+          <a:ea typeface="+mn-ea"/>
+          <a:cs typeface="+mn-cs"/>
           <a:sym typeface="Calibri"/>
         </a:defRPr>
       </a:lvl8pPr>
@@ -2230,9 +2219,9 @@
             <a:srgbClr val="000000"/>
           </a:solidFill>
           <a:uFillTx/>
-          <a:latin typeface="+mj-lt"/>
-          <a:ea typeface="+mj-ea"/>
-          <a:cs typeface="+mj-cs"/>
+          <a:latin typeface="+mn-lt"/>
+          <a:ea typeface="+mn-ea"/>
+          <a:cs typeface="+mn-cs"/>
           <a:sym typeface="Calibri"/>
         </a:defRPr>
       </a:lvl9pPr>
@@ -2258,9 +2247,9 @@
             <a:srgbClr val="000000"/>
           </a:solidFill>
           <a:uFillTx/>
-          <a:latin typeface="+mj-lt"/>
-          <a:ea typeface="+mj-ea"/>
-          <a:cs typeface="+mj-cs"/>
+          <a:latin typeface="+mn-lt"/>
+          <a:ea typeface="+mn-ea"/>
+          <a:cs typeface="+mn-cs"/>
           <a:sym typeface="Calibri"/>
         </a:defRPr>
       </a:lvl1pPr>
@@ -2284,9 +2273,9 @@
             <a:srgbClr val="000000"/>
           </a:solidFill>
           <a:uFillTx/>
-          <a:latin typeface="+mj-lt"/>
-          <a:ea typeface="+mj-ea"/>
-          <a:cs typeface="+mj-cs"/>
+          <a:latin typeface="+mn-lt"/>
+          <a:ea typeface="+mn-ea"/>
+          <a:cs typeface="+mn-cs"/>
           <a:sym typeface="Calibri"/>
         </a:defRPr>
       </a:lvl2pPr>
@@ -2310,9 +2299,9 @@
             <a:srgbClr val="000000"/>
           </a:solidFill>
           <a:uFillTx/>
-          <a:latin typeface="+mj-lt"/>
-          <a:ea typeface="+mj-ea"/>
-          <a:cs typeface="+mj-cs"/>
+          <a:latin typeface="+mn-lt"/>
+          <a:ea typeface="+mn-ea"/>
+          <a:cs typeface="+mn-cs"/>
           <a:sym typeface="Calibri"/>
         </a:defRPr>
       </a:lvl3pPr>
@@ -2336,9 +2325,9 @@
             <a:srgbClr val="000000"/>
           </a:solidFill>
           <a:uFillTx/>
-          <a:latin typeface="+mj-lt"/>
-          <a:ea typeface="+mj-ea"/>
-          <a:cs typeface="+mj-cs"/>
+          <a:latin typeface="+mn-lt"/>
+          <a:ea typeface="+mn-ea"/>
+          <a:cs typeface="+mn-cs"/>
           <a:sym typeface="Calibri"/>
         </a:defRPr>
       </a:lvl4pPr>
@@ -2362,9 +2351,9 @@
             <a:srgbClr val="000000"/>
           </a:solidFill>
           <a:uFillTx/>
-          <a:latin typeface="+mj-lt"/>
-          <a:ea typeface="+mj-ea"/>
-          <a:cs typeface="+mj-cs"/>
+          <a:latin typeface="+mn-lt"/>
+          <a:ea typeface="+mn-ea"/>
+          <a:cs typeface="+mn-cs"/>
           <a:sym typeface="Calibri"/>
         </a:defRPr>
       </a:lvl5pPr>
@@ -2388,9 +2377,9 @@
             <a:srgbClr val="000000"/>
           </a:solidFill>
           <a:uFillTx/>
-          <a:latin typeface="+mj-lt"/>
-          <a:ea typeface="+mj-ea"/>
-          <a:cs typeface="+mj-cs"/>
+          <a:latin typeface="+mn-lt"/>
+          <a:ea typeface="+mn-ea"/>
+          <a:cs typeface="+mn-cs"/>
           <a:sym typeface="Calibri"/>
         </a:defRPr>
       </a:lvl6pPr>
@@ -2414,9 +2403,9 @@
             <a:srgbClr val="000000"/>
           </a:solidFill>
           <a:uFillTx/>
-          <a:latin typeface="+mj-lt"/>
-          <a:ea typeface="+mj-ea"/>
-          <a:cs typeface="+mj-cs"/>
+          <a:latin typeface="+mn-lt"/>
+          <a:ea typeface="+mn-ea"/>
+          <a:cs typeface="+mn-cs"/>
           <a:sym typeface="Calibri"/>
         </a:defRPr>
       </a:lvl7pPr>
@@ -2440,9 +2429,9 @@
             <a:srgbClr val="000000"/>
           </a:solidFill>
           <a:uFillTx/>
-          <a:latin typeface="+mj-lt"/>
-          <a:ea typeface="+mj-ea"/>
-          <a:cs typeface="+mj-cs"/>
+          <a:latin typeface="+mn-lt"/>
+          <a:ea typeface="+mn-ea"/>
+          <a:cs typeface="+mn-cs"/>
           <a:sym typeface="Calibri"/>
         </a:defRPr>
       </a:lvl8pPr>
@@ -2466,9 +2455,9 @@
             <a:srgbClr val="000000"/>
           </a:solidFill>
           <a:uFillTx/>
-          <a:latin typeface="+mj-lt"/>
-          <a:ea typeface="+mj-ea"/>
-          <a:cs typeface="+mj-cs"/>
+          <a:latin typeface="+mn-lt"/>
+          <a:ea typeface="+mn-ea"/>
+          <a:cs typeface="+mn-cs"/>
           <a:sym typeface="Calibri"/>
         </a:defRPr>
       </a:lvl9pPr>
@@ -2500,7 +2489,7 @@
           <a:sym typeface="Calibri"/>
         </a:defRPr>
       </a:lvl1pPr>
-      <a:lvl2pPr marL="0" marR="0" indent="457200" algn="r" defTabSz="457200" rtl="0" latinLnBrk="0">
+      <a:lvl2pPr marL="0" marR="0" indent="0" algn="r" defTabSz="457200" rtl="0" latinLnBrk="0">
         <a:lnSpc>
           <a:spcPct val="100000"/>
         </a:lnSpc>
@@ -2526,7 +2515,7 @@
           <a:sym typeface="Calibri"/>
         </a:defRPr>
       </a:lvl2pPr>
-      <a:lvl3pPr marL="0" marR="0" indent="914400" algn="r" defTabSz="457200" rtl="0" latinLnBrk="0">
+      <a:lvl3pPr marL="0" marR="0" indent="0" algn="r" defTabSz="457200" rtl="0" latinLnBrk="0">
         <a:lnSpc>
           <a:spcPct val="100000"/>
         </a:lnSpc>
@@ -2552,7 +2541,7 @@
           <a:sym typeface="Calibri"/>
         </a:defRPr>
       </a:lvl3pPr>
-      <a:lvl4pPr marL="0" marR="0" indent="1371600" algn="r" defTabSz="457200" rtl="0" latinLnBrk="0">
+      <a:lvl4pPr marL="0" marR="0" indent="0" algn="r" defTabSz="457200" rtl="0" latinLnBrk="0">
         <a:lnSpc>
           <a:spcPct val="100000"/>
         </a:lnSpc>
@@ -2578,7 +2567,7 @@
           <a:sym typeface="Calibri"/>
         </a:defRPr>
       </a:lvl4pPr>
-      <a:lvl5pPr marL="0" marR="0" indent="1828800" algn="r" defTabSz="457200" rtl="0" latinLnBrk="0">
+      <a:lvl5pPr marL="0" marR="0" indent="0" algn="r" defTabSz="457200" rtl="0" latinLnBrk="0">
         <a:lnSpc>
           <a:spcPct val="100000"/>
         </a:lnSpc>
@@ -2604,7 +2593,7 @@
           <a:sym typeface="Calibri"/>
         </a:defRPr>
       </a:lvl5pPr>
-      <a:lvl6pPr marL="0" marR="0" indent="2286000" algn="r" defTabSz="457200" rtl="0" latinLnBrk="0">
+      <a:lvl6pPr marL="0" marR="0" indent="0" algn="r" defTabSz="457200" rtl="0" latinLnBrk="0">
         <a:lnSpc>
           <a:spcPct val="100000"/>
         </a:lnSpc>
@@ -2630,7 +2619,7 @@
           <a:sym typeface="Calibri"/>
         </a:defRPr>
       </a:lvl6pPr>
-      <a:lvl7pPr marL="0" marR="0" indent="2743200" algn="r" defTabSz="457200" rtl="0" latinLnBrk="0">
+      <a:lvl7pPr marL="0" marR="0" indent="0" algn="r" defTabSz="457200" rtl="0" latinLnBrk="0">
         <a:lnSpc>
           <a:spcPct val="100000"/>
         </a:lnSpc>
@@ -2656,7 +2645,7 @@
           <a:sym typeface="Calibri"/>
         </a:defRPr>
       </a:lvl7pPr>
-      <a:lvl8pPr marL="0" marR="0" indent="3200400" algn="r" defTabSz="457200" rtl="0" latinLnBrk="0">
+      <a:lvl8pPr marL="0" marR="0" indent="0" algn="r" defTabSz="457200" rtl="0" latinLnBrk="0">
         <a:lnSpc>
           <a:spcPct val="100000"/>
         </a:lnSpc>
@@ -2682,7 +2671,7 @@
           <a:sym typeface="Calibri"/>
         </a:defRPr>
       </a:lvl8pPr>
-      <a:lvl9pPr marL="0" marR="0" indent="3657600" algn="r" defTabSz="457200" rtl="0" latinLnBrk="0">
+      <a:lvl9pPr marL="0" marR="0" indent="0" algn="r" defTabSz="457200" rtl="0" latinLnBrk="0">
         <a:lnSpc>
           <a:spcPct val="100000"/>
         </a:lnSpc>
@@ -2756,7 +2745,7 @@
           <a:p>
             <a:pPr/>
             <a:r>
-              <a:t>Deterministic RAG for SEC Filings</a:t>
+              <a:t>Agentic RAG for SEC Filings</a:t>
             </a:r>
           </a:p>
         </p:txBody>
@@ -2778,41 +2767,27 @@
           <a:bodyPr/>
           <a:lstStyle/>
           <a:p>
-            <a:pPr defTabSz="352043">
+            <a:pPr defTabSz="352042">
               <a:spcBef>
                 <a:spcPts val="500"/>
               </a:spcBef>
-              <a:defRPr sz="2464"/>
-            </a:pPr>
-            <a:r>
-              <a:t>Architecture, Execution Controls, and MRM</a:t>
-            </a:r>
-          </a:p>
-          <a:p>
-            <a:pPr defTabSz="352043">
+              <a:defRPr sz="2400"/>
+            </a:pPr>
+          </a:p>
+          <a:p>
+            <a:pPr defTabSz="352042">
               <a:spcBef>
                 <a:spcPts val="500"/>
               </a:spcBef>
-              <a:defRPr sz="2464"/>
-            </a:pPr>
-            <a:r>
-              <a:t>CIB Applied AI</a:t>
-            </a:r>
-          </a:p>
-          <a:p>
-            <a:pPr defTabSz="352043">
+              <a:defRPr sz="2400"/>
+            </a:pPr>
+          </a:p>
+          <a:p>
+            <a:pPr defTabSz="352042">
               <a:spcBef>
                 <a:spcPts val="500"/>
               </a:spcBef>
-              <a:defRPr sz="2464"/>
-            </a:pPr>
-          </a:p>
-          <a:p>
-            <a:pPr defTabSz="352043">
-              <a:spcBef>
-                <a:spcPts val="500"/>
-              </a:spcBef>
-              <a:defRPr sz="2464"/>
+              <a:defRPr sz="2400"/>
             </a:pPr>
             <a:r>
               <a:t>Venkatesh Giri</a:t>
@@ -2828,8 +2803,8 @@
         </p:nvSpPr>
         <p:spPr>
           <a:xfrm>
-            <a:off x="0" y="-1"/>
-            <a:ext cx="9144000" cy="137162"/>
+            <a:off x="0" y="-2"/>
+            <a:ext cx="9144000" cy="137164"/>
           </a:xfrm>
           <a:prstGeom prst="rect">
             <a:avLst/>
@@ -2851,7 +2826,7 @@
           </a:effectLst>
         </p:spPr>
         <p:txBody>
-          <a:bodyPr lIns="45719" rIns="45719" anchor="ctr"/>
+          <a:bodyPr lIns="45718" tIns="45718" rIns="45718" bIns="45718" anchor="ctr"/>
           <a:lstStyle/>
           <a:p>
             <a:pPr algn="ctr">
@@ -2859,6 +2834,10 @@
                 <a:solidFill>
                   <a:srgbClr val="FFFFFF"/>
                 </a:solidFill>
+                <a:latin typeface="+mn-lt"/>
+                <a:ea typeface="+mn-ea"/>
+                <a:cs typeface="+mn-cs"/>
+                <a:sym typeface="Calibri"/>
               </a:defRPr>
             </a:pPr>
           </a:p>
@@ -2899,14 +2878,121 @@
       </p:grpSpPr>
       <p:sp>
         <p:nvSpPr>
-          <p:cNvPr id="131" name="Rectangle 1"/>
+          <p:cNvPr id="131" name="Title 1"/>
+          <p:cNvSpPr txBox="1"/>
+          <p:nvPr>
+            <p:ph type="title"/>
+          </p:nvPr>
+        </p:nvSpPr>
+        <p:spPr>
+          <a:xfrm>
+            <a:off x="457200" y="274638"/>
+            <a:ext cx="8229600" cy="1143001"/>
+          </a:xfrm>
+          <a:prstGeom prst="rect">
+            <a:avLst/>
+          </a:prstGeom>
+        </p:spPr>
+        <p:txBody>
+          <a:bodyPr/>
+          <a:lstStyle/>
+          <a:p>
+            <a:pPr/>
+            <a:r>
+              <a:t>Model Risk Management (MRM)</a:t>
+            </a:r>
+          </a:p>
+        </p:txBody>
+      </p:sp>
+      <p:sp>
+        <p:nvSpPr>
+          <p:cNvPr id="132" name="Content Placeholder 2"/>
+          <p:cNvSpPr txBox="1"/>
+          <p:nvPr>
+            <p:ph type="body" idx="1"/>
+          </p:nvPr>
+        </p:nvSpPr>
+        <p:spPr>
+          <a:xfrm>
+            <a:off x="457200" y="1600200"/>
+            <a:ext cx="8229600" cy="4525963"/>
+          </a:xfrm>
+          <a:prstGeom prst="rect">
+            <a:avLst/>
+          </a:prstGeom>
+        </p:spPr>
+        <p:txBody>
+          <a:bodyPr/>
+          <a:lstStyle/>
+          <a:p>
+            <a:pPr marL="332613" indent="-332613" defTabSz="443483">
+              <a:defRPr sz="3100"/>
+            </a:pPr>
+            <a:r>
+              <a:t>100% Traceability</a:t>
+            </a:r>
+          </a:p>
+          <a:p>
+            <a:pPr lvl="1" marL="720661" indent="-277177" defTabSz="443483">
+              <a:spcBef>
+                <a:spcPts val="600"/>
+              </a:spcBef>
+              <a:defRPr sz="2700"/>
+            </a:pPr>
+            <a:r>
+              <a:t>The Pydantic state object records every SQL match, candidate score, and node transition.</a:t>
+            </a:r>
+          </a:p>
+          <a:p>
+            <a:pPr marL="332613" indent="-332613" defTabSz="443483">
+              <a:defRPr sz="3100"/>
+            </a:pPr>
+            <a:r>
+              <a:t>Audit-Ready Logs</a:t>
+            </a:r>
+          </a:p>
+          <a:p>
+            <a:pPr lvl="1" marL="720661" indent="-277177" defTabSz="443483">
+              <a:spcBef>
+                <a:spcPts val="600"/>
+              </a:spcBef>
+              <a:defRPr sz="2700"/>
+            </a:pPr>
+            <a:r>
+              <a:t>Execution traces can be piped directly to internal telemetry platforms for MRM compliance.</a:t>
+            </a:r>
+          </a:p>
+          <a:p>
+            <a:pPr marL="332613" indent="-332613" defTabSz="443483">
+              <a:defRPr sz="3100"/>
+            </a:pPr>
+            <a:r>
+              <a:t>Deterministic Citations</a:t>
+            </a:r>
+          </a:p>
+          <a:p>
+            <a:pPr lvl="1" marL="720661" indent="-277177" defTabSz="443483">
+              <a:spcBef>
+                <a:spcPts val="600"/>
+              </a:spcBef>
+              <a:defRPr sz="2700"/>
+            </a:pPr>
+            <a:r>
+              <a:t>Every generated claim is hard-bound to a specific chunk_id and SEC canonical source URL.</a:t>
+            </a:r>
+          </a:p>
+        </p:txBody>
+      </p:sp>
+      <p:sp>
+        <p:nvSpPr>
+          <p:cNvPr id="133" name="Rectangle 3"/>
           <p:cNvSpPr/>
           <p:nvPr/>
         </p:nvSpPr>
         <p:spPr>
           <a:xfrm>
-            <a:off x="0" y="-1"/>
-            <a:ext cx="9144000" cy="137162"/>
+            <a:off x="0" y="-2"/>
+            <a:ext cx="9144000" cy="137164"/>
           </a:xfrm>
           <a:prstGeom prst="rect">
             <a:avLst/>
@@ -2928,7 +3014,7 @@
           </a:effectLst>
         </p:spPr>
         <p:txBody>
-          <a:bodyPr lIns="45719" rIns="45719" anchor="ctr"/>
+          <a:bodyPr lIns="45718" tIns="45718" rIns="45718" bIns="45718" anchor="ctr"/>
           <a:lstStyle/>
           <a:p>
             <a:pPr algn="ctr">
@@ -2936,81 +3022,15 @@
                 <a:solidFill>
                   <a:srgbClr val="FFFFFF"/>
                 </a:solidFill>
+                <a:latin typeface="+mn-lt"/>
+                <a:ea typeface="+mn-ea"/>
+                <a:cs typeface="+mn-cs"/>
+                <a:sym typeface="Calibri"/>
               </a:defRPr>
             </a:pPr>
           </a:p>
         </p:txBody>
       </p:sp>
-      <p:sp>
-        <p:nvSpPr>
-          <p:cNvPr id="132" name="TextBox 2"/>
-          <p:cNvSpPr txBox="1"/>
-          <p:nvPr/>
-        </p:nvSpPr>
-        <p:spPr>
-          <a:xfrm>
-            <a:off x="313527" y="304673"/>
-            <a:ext cx="3196194" cy="789147"/>
-          </a:xfrm>
-          <a:prstGeom prst="rect">
-            <a:avLst/>
-          </a:prstGeom>
-          <a:ln w="12700">
-            <a:miter lim="400000"/>
-          </a:ln>
-          <a:extLst>
-            <a:ext uri="{C572A759-6A51-4108-AA02-DFA0A04FC94B}">
-              <ma14:wrappingTextBoxFlag xmlns:ma14="http://schemas.microsoft.com/office/mac/drawingml/2011/main" val="1"/>
-            </a:ext>
-          </a:extLst>
-        </p:spPr>
-        <p:txBody>
-          <a:bodyPr wrap="none" lIns="45719" rIns="45719">
-            <a:spAutoFit/>
-          </a:bodyPr>
-          <a:lstStyle/>
-          <a:p>
-            <a:pPr/>
-          </a:p>
-          <a:p>
-            <a:pPr>
-              <a:defRPr b="1" sz="3200"/>
-            </a:pPr>
-            <a:r>
-              <a:t>User Interface (UI)</a:t>
-            </a:r>
-          </a:p>
-        </p:txBody>
-      </p:sp>
-      <p:pic>
-        <p:nvPicPr>
-          <p:cNvPr id="133" name="unknown.png" descr="unknown.png"/>
-          <p:cNvPicPr>
-            <a:picLocks noChangeAspect="1"/>
-          </p:cNvPicPr>
-          <p:nvPr/>
-        </p:nvPicPr>
-        <p:blipFill>
-          <a:blip r:embed="rId2">
-            <a:extLst/>
-          </a:blip>
-          <a:stretch>
-            <a:fillRect/>
-          </a:stretch>
-        </p:blipFill>
-        <p:spPr>
-          <a:xfrm>
-            <a:off x="101446" y="1256570"/>
-            <a:ext cx="8941108" cy="4568348"/>
-          </a:xfrm>
-          <a:prstGeom prst="rect">
-            <a:avLst/>
-          </a:prstGeom>
-          <a:ln w="12700">
-            <a:miter lim="400000"/>
-          </a:ln>
-        </p:spPr>
-      </p:pic>
     </p:spTree>
   </p:cSld>
   <p:clrMapOvr>
@@ -3052,8 +3072,8 @@
         </p:nvSpPr>
         <p:spPr>
           <a:xfrm>
-            <a:off x="0" y="-1"/>
-            <a:ext cx="9144000" cy="137162"/>
+            <a:off x="0" y="-2"/>
+            <a:ext cx="9144000" cy="137164"/>
           </a:xfrm>
           <a:prstGeom prst="rect">
             <a:avLst/>
@@ -3075,7 +3095,7 @@
           </a:effectLst>
         </p:spPr>
         <p:txBody>
-          <a:bodyPr lIns="45719" rIns="45719" anchor="ctr"/>
+          <a:bodyPr lIns="45718" tIns="45718" rIns="45718" bIns="45718" anchor="ctr"/>
           <a:lstStyle/>
           <a:p>
             <a:pPr algn="ctr">
@@ -3083,6 +3103,10 @@
                 <a:solidFill>
                   <a:srgbClr val="FFFFFF"/>
                 </a:solidFill>
+                <a:latin typeface="+mn-lt"/>
+                <a:ea typeface="+mn-ea"/>
+                <a:cs typeface="+mn-cs"/>
+                <a:sym typeface="Calibri"/>
               </a:defRPr>
             </a:pPr>
           </a:p>
@@ -3096,8 +3120,8 @@
         </p:nvSpPr>
         <p:spPr>
           <a:xfrm>
-            <a:off x="502919" y="182879"/>
-            <a:ext cx="6181687" cy="992348"/>
+            <a:off x="313526" y="304673"/>
+            <a:ext cx="3196193" cy="789146"/>
           </a:xfrm>
           <a:prstGeom prst="rect">
             <a:avLst/>
@@ -3112,60 +3136,38 @@
           </a:extLst>
         </p:spPr>
         <p:txBody>
-          <a:bodyPr wrap="none" lIns="45719" rIns="45719">
+          <a:bodyPr wrap="none" lIns="45718" tIns="45718" rIns="45718" bIns="45718">
             <a:spAutoFit/>
           </a:bodyPr>
           <a:lstStyle/>
           <a:p>
             <a:pPr>
-              <a:defRPr b="1" sz="3200"/>
-            </a:pPr>
-            <a:r>
-              <a:t>Examples of the Agents : </a:t>
-            </a:r>
-            <a:br/>
-            <a:r>
-              <a:t>1. Multi planning with planner node</a:t>
-            </a:r>
-          </a:p>
-        </p:txBody>
-      </p:sp>
-      <p:sp>
-        <p:nvSpPr>
-          <p:cNvPr id="137" name="TextBox 3"/>
-          <p:cNvSpPr txBox="1"/>
-          <p:nvPr/>
-        </p:nvSpPr>
-        <p:spPr>
-          <a:xfrm>
-            <a:off x="502919" y="914400"/>
-            <a:ext cx="127001" cy="632282"/>
-          </a:xfrm>
-          <a:prstGeom prst="rect">
-            <a:avLst/>
-          </a:prstGeom>
-          <a:ln w="12700">
-            <a:miter lim="400000"/>
-          </a:ln>
-          <a:extLst>
-            <a:ext uri="{C572A759-6A51-4108-AA02-DFA0A04FC94B}">
-              <ma14:wrappingTextBoxFlag xmlns:ma14="http://schemas.microsoft.com/office/mac/drawingml/2011/main" val="1"/>
-            </a:ext>
-          </a:extLst>
-        </p:spPr>
-        <p:txBody>
-          <a:bodyPr wrap="none" lIns="45719" rIns="45719">
-            <a:spAutoFit/>
-          </a:bodyPr>
-          <a:lstStyle/>
-          <a:p>
-            <a:pPr/>
+              <a:defRPr>
+                <a:latin typeface="+mn-lt"/>
+                <a:ea typeface="+mn-ea"/>
+                <a:cs typeface="+mn-cs"/>
+                <a:sym typeface="Calibri"/>
+              </a:defRPr>
+            </a:pPr>
+          </a:p>
+          <a:p>
+            <a:pPr>
+              <a:defRPr b="1" sz="3200">
+                <a:latin typeface="+mn-lt"/>
+                <a:ea typeface="+mn-ea"/>
+                <a:cs typeface="+mn-cs"/>
+                <a:sym typeface="Calibri"/>
+              </a:defRPr>
+            </a:pPr>
+            <a:r>
+              <a:t>User Interface (UI)</a:t>
+            </a:r>
           </a:p>
         </p:txBody>
       </p:sp>
       <p:pic>
         <p:nvPicPr>
-          <p:cNvPr id="138" name="unknown.png" descr="unknown.png"/>
+          <p:cNvPr id="137" name="unknown.png" descr="unknown.png"/>
           <p:cNvPicPr>
             <a:picLocks noChangeAspect="1"/>
           </p:cNvPicPr>
@@ -3175,15 +3177,14 @@
           <a:blip r:embed="rId2">
             <a:extLst/>
           </a:blip>
-          <a:srcRect l="0" t="0" r="4971" b="0"/>
           <a:stretch>
             <a:fillRect/>
           </a:stretch>
         </p:blipFill>
         <p:spPr>
           <a:xfrm>
-            <a:off x="74810" y="1373524"/>
-            <a:ext cx="8994353" cy="4273994"/>
+            <a:off x="101446" y="1256570"/>
+            <a:ext cx="8941108" cy="4568348"/>
           </a:xfrm>
           <a:prstGeom prst="rect">
             <a:avLst/>
@@ -3228,14 +3229,14 @@
       </p:grpSpPr>
       <p:sp>
         <p:nvSpPr>
-          <p:cNvPr id="140" name="Rectangle 1"/>
+          <p:cNvPr id="139" name="Rectangle 1"/>
           <p:cNvSpPr/>
           <p:nvPr/>
         </p:nvSpPr>
         <p:spPr>
           <a:xfrm>
-            <a:off x="0" y="-1"/>
-            <a:ext cx="9144000" cy="137162"/>
+            <a:off x="0" y="-2"/>
+            <a:ext cx="9144000" cy="137164"/>
           </a:xfrm>
           <a:prstGeom prst="rect">
             <a:avLst/>
@@ -3257,7 +3258,7 @@
           </a:effectLst>
         </p:spPr>
         <p:txBody>
-          <a:bodyPr lIns="45719" rIns="45719" anchor="ctr"/>
+          <a:bodyPr lIns="45718" tIns="45718" rIns="45718" bIns="45718" anchor="ctr"/>
           <a:lstStyle/>
           <a:p>
             <a:pPr algn="ctr">
@@ -3265,6 +3266,10 @@
                 <a:solidFill>
                   <a:srgbClr val="FFFFFF"/>
                 </a:solidFill>
+                <a:latin typeface="+mn-lt"/>
+                <a:ea typeface="+mn-ea"/>
+                <a:cs typeface="+mn-cs"/>
+                <a:sym typeface="Calibri"/>
               </a:defRPr>
             </a:pPr>
           </a:p>
@@ -3272,14 +3277,14 @@
       </p:sp>
       <p:sp>
         <p:nvSpPr>
-          <p:cNvPr id="141" name="TextBox 2"/>
+          <p:cNvPr id="140" name="TextBox 2"/>
           <p:cNvSpPr txBox="1"/>
           <p:nvPr/>
         </p:nvSpPr>
         <p:spPr>
           <a:xfrm>
-            <a:off x="502919" y="182879"/>
-            <a:ext cx="8267662" cy="789148"/>
+            <a:off x="502919" y="182880"/>
+            <a:ext cx="6181684" cy="992345"/>
           </a:xfrm>
           <a:prstGeom prst="rect">
             <a:avLst/>
@@ -3294,26 +3299,32 @@
           </a:extLst>
         </p:spPr>
         <p:txBody>
-          <a:bodyPr wrap="none" lIns="45719" rIns="45719">
+          <a:bodyPr wrap="none" lIns="45718" tIns="45718" rIns="45718" bIns="45718">
             <a:spAutoFit/>
           </a:bodyPr>
           <a:lstStyle/>
           <a:p>
-            <a:pPr/>
-          </a:p>
-          <a:p>
             <a:pPr>
-              <a:defRPr b="1" sz="3200"/>
-            </a:pPr>
-            <a:r>
-              <a:t>2. Clarify: Resolving Ambiguity with Clarify Node</a:t>
+              <a:defRPr b="1" sz="3200">
+                <a:latin typeface="+mn-lt"/>
+                <a:ea typeface="+mn-ea"/>
+                <a:cs typeface="+mn-cs"/>
+                <a:sym typeface="Calibri"/>
+              </a:defRPr>
+            </a:pPr>
+            <a:r>
+              <a:t>Examples of the Agents : </a:t>
+            </a:r>
+            <a:br/>
+            <a:r>
+              <a:t>1. Multi planning with planner node</a:t>
             </a:r>
           </a:p>
         </p:txBody>
       </p:sp>
       <p:pic>
         <p:nvPicPr>
-          <p:cNvPr id="142" name="unknown.png" descr="unknown.png"/>
+          <p:cNvPr id="141" name="unknown.png" descr="unknown.png"/>
           <p:cNvPicPr>
             <a:picLocks noChangeAspect="1"/>
           </p:cNvPicPr>
@@ -3323,15 +3334,15 @@
           <a:blip r:embed="rId2">
             <a:extLst/>
           </a:blip>
-          <a:srcRect l="567" t="10546" r="4884" b="0"/>
+          <a:srcRect l="0" t="0" r="4971" b="0"/>
           <a:stretch>
             <a:fillRect/>
           </a:stretch>
         </p:blipFill>
         <p:spPr>
           <a:xfrm>
-            <a:off x="145851" y="1755786"/>
-            <a:ext cx="8852235" cy="3776824"/>
+            <a:off x="74810" y="1373524"/>
+            <a:ext cx="8994354" cy="4273995"/>
           </a:xfrm>
           <a:prstGeom prst="rect">
             <a:avLst/>
@@ -3351,103 +3362,6 @@
 </file>
 
 <file path=ppt/slides/slide13.xml><?xml version="1.0" encoding="utf-8"?>
-<p:sld xmlns:a="http://schemas.openxmlformats.org/drawingml/2006/main" xmlns:r="http://schemas.openxmlformats.org/officeDocument/2006/relationships" xmlns:p="http://schemas.openxmlformats.org/presentationml/2006/main" xmlns:m="http://schemas.openxmlformats.org/officeDocument/2006/math" xmlns:a14="http://schemas.microsoft.com/office/drawing/2010/main" showMasterSp="1" showMasterPhAnim="1">
-  <p:cSld>
-    <p:spTree>
-      <p:nvGrpSpPr>
-        <p:cNvPr id="1" name=""/>
-        <p:cNvGrpSpPr/>
-        <p:nvPr/>
-      </p:nvGrpSpPr>
-      <p:grpSpPr>
-        <a:xfrm>
-          <a:off x="0" y="0"/>
-          <a:ext cx="0" cy="0"/>
-          <a:chOff x="0" y="0"/>
-          <a:chExt cx="0" cy="0"/>
-        </a:xfrm>
-      </p:grpSpPr>
-      <p:sp>
-        <p:nvSpPr>
-          <p:cNvPr id="144" name="Clarify: Multi-turn"/>
-          <p:cNvSpPr txBox="1"/>
-          <p:nvPr/>
-        </p:nvSpPr>
-        <p:spPr>
-          <a:xfrm>
-            <a:off x="262585" y="133732"/>
-            <a:ext cx="3150752" cy="789147"/>
-          </a:xfrm>
-          <a:prstGeom prst="rect">
-            <a:avLst/>
-          </a:prstGeom>
-          <a:ln w="12700">
-            <a:miter lim="400000"/>
-          </a:ln>
-          <a:extLst>
-            <a:ext uri="{C572A759-6A51-4108-AA02-DFA0A04FC94B}">
-              <ma14:wrappingTextBoxFlag xmlns:ma14="http://schemas.microsoft.com/office/mac/drawingml/2011/main" val="1"/>
-            </a:ext>
-          </a:extLst>
-        </p:spPr>
-        <p:txBody>
-          <a:bodyPr wrap="none" lIns="45719" rIns="45719">
-            <a:spAutoFit/>
-          </a:bodyPr>
-          <a:lstStyle/>
-          <a:p>
-            <a:pPr/>
-          </a:p>
-          <a:p>
-            <a:pPr>
-              <a:defRPr b="1" sz="3200"/>
-            </a:pPr>
-            <a:r>
-              <a:t>Clarify: Multi-turn</a:t>
-            </a:r>
-          </a:p>
-        </p:txBody>
-      </p:sp>
-      <p:pic>
-        <p:nvPicPr>
-          <p:cNvPr id="145" name="unknown.png" descr="unknown.png"/>
-          <p:cNvPicPr>
-            <a:picLocks noChangeAspect="1"/>
-          </p:cNvPicPr>
-          <p:nvPr/>
-        </p:nvPicPr>
-        <p:blipFill>
-          <a:blip r:embed="rId2">
-            <a:extLst/>
-          </a:blip>
-          <a:srcRect l="12322" t="19631" r="0" b="257"/>
-          <a:stretch>
-            <a:fillRect/>
-          </a:stretch>
-        </p:blipFill>
-        <p:spPr>
-          <a:xfrm>
-            <a:off x="108476" y="1296866"/>
-            <a:ext cx="8712983" cy="4104946"/>
-          </a:xfrm>
-          <a:prstGeom prst="rect">
-            <a:avLst/>
-          </a:prstGeom>
-          <a:ln w="12700">
-            <a:miter lim="400000"/>
-          </a:ln>
-        </p:spPr>
-      </p:pic>
-    </p:spTree>
-  </p:cSld>
-  <p:clrMapOvr>
-    <a:masterClrMapping/>
-  </p:clrMapOvr>
-  <p:transition xmlns:p14="http://schemas.microsoft.com/office/powerpoint/2010/main" spd="med" advClick="1"/>
-</p:sld>
-</file>
-
-<file path=ppt/slides/slide14.xml><?xml version="1.0" encoding="utf-8"?>
 <p:sld xmlns:a="http://schemas.openxmlformats.org/drawingml/2006/main" xmlns:r="http://schemas.openxmlformats.org/officeDocument/2006/relationships" xmlns:p="http://schemas.openxmlformats.org/presentationml/2006/main" xmlns:m="http://schemas.openxmlformats.org/officeDocument/2006/math" xmlns:a14="http://schemas.microsoft.com/office/drawing/2010/main" showMasterSp="1" showMasterPhAnim="1">
   <p:cSld>
     <p:bg>
@@ -3473,14 +3387,14 @@
       </p:grpSpPr>
       <p:sp>
         <p:nvSpPr>
-          <p:cNvPr id="147" name="Rectangle 1"/>
+          <p:cNvPr id="143" name="Rectangle 1"/>
           <p:cNvSpPr/>
           <p:nvPr/>
         </p:nvSpPr>
         <p:spPr>
           <a:xfrm>
-            <a:off x="0" y="-1"/>
-            <a:ext cx="9144000" cy="137162"/>
+            <a:off x="0" y="-2"/>
+            <a:ext cx="9144000" cy="137164"/>
           </a:xfrm>
           <a:prstGeom prst="rect">
             <a:avLst/>
@@ -3502,7 +3416,7 @@
           </a:effectLst>
         </p:spPr>
         <p:txBody>
-          <a:bodyPr lIns="45719" rIns="45719" anchor="ctr"/>
+          <a:bodyPr lIns="45718" tIns="45718" rIns="45718" bIns="45718" anchor="ctr"/>
           <a:lstStyle/>
           <a:p>
             <a:pPr algn="ctr">
@@ -3510,6 +3424,10 @@
                 <a:solidFill>
                   <a:srgbClr val="FFFFFF"/>
                 </a:solidFill>
+                <a:latin typeface="+mn-lt"/>
+                <a:ea typeface="+mn-ea"/>
+                <a:cs typeface="+mn-cs"/>
+                <a:sym typeface="Calibri"/>
               </a:defRPr>
             </a:pPr>
           </a:p>
@@ -3517,14 +3435,14 @@
       </p:sp>
       <p:sp>
         <p:nvSpPr>
-          <p:cNvPr id="148" name="TextBox 2"/>
+          <p:cNvPr id="144" name="TextBox 2"/>
           <p:cNvSpPr txBox="1"/>
           <p:nvPr/>
         </p:nvSpPr>
         <p:spPr>
           <a:xfrm>
             <a:off x="502919" y="182879"/>
-            <a:ext cx="6788112" cy="789148"/>
+            <a:ext cx="8267659" cy="789146"/>
           </a:xfrm>
           <a:prstGeom prst="rect">
             <a:avLst/>
@@ -3539,26 +3457,311 @@
           </a:extLst>
         </p:spPr>
         <p:txBody>
-          <a:bodyPr wrap="none" lIns="45719" rIns="45719">
+          <a:bodyPr wrap="none" lIns="45718" tIns="45718" rIns="45718" bIns="45718">
             <a:spAutoFit/>
           </a:bodyPr>
           <a:lstStyle/>
           <a:p>
-            <a:pPr/>
-          </a:p>
-          <a:p>
             <a:pPr>
-              <a:defRPr b="1" sz="3200"/>
-            </a:pPr>
-            <a:r>
-              <a:t>3. Context Verification with Verify Node</a:t>
+              <a:defRPr>
+                <a:latin typeface="+mn-lt"/>
+                <a:ea typeface="+mn-ea"/>
+                <a:cs typeface="+mn-cs"/>
+                <a:sym typeface="Calibri"/>
+              </a:defRPr>
+            </a:pPr>
+          </a:p>
+          <a:p>
+            <a:pPr>
+              <a:defRPr b="1" sz="3200">
+                <a:latin typeface="+mn-lt"/>
+                <a:ea typeface="+mn-ea"/>
+                <a:cs typeface="+mn-cs"/>
+                <a:sym typeface="Calibri"/>
+              </a:defRPr>
+            </a:pPr>
+            <a:r>
+              <a:t>2. Clarify: Resolving Ambiguity with Clarify Node</a:t>
             </a:r>
           </a:p>
         </p:txBody>
       </p:sp>
       <p:pic>
         <p:nvPicPr>
-          <p:cNvPr id="149" name="pasted-movie.png" descr="pasted-movie.png"/>
+          <p:cNvPr id="145" name="unknown.png" descr="unknown.png"/>
+          <p:cNvPicPr>
+            <a:picLocks noChangeAspect="1"/>
+          </p:cNvPicPr>
+          <p:nvPr/>
+        </p:nvPicPr>
+        <p:blipFill>
+          <a:blip r:embed="rId2">
+            <a:extLst/>
+          </a:blip>
+          <a:srcRect l="567" t="10546" r="4884" b="0"/>
+          <a:stretch>
+            <a:fillRect/>
+          </a:stretch>
+        </p:blipFill>
+        <p:spPr>
+          <a:xfrm>
+            <a:off x="145850" y="1755786"/>
+            <a:ext cx="8852236" cy="3776825"/>
+          </a:xfrm>
+          <a:prstGeom prst="rect">
+            <a:avLst/>
+          </a:prstGeom>
+          <a:ln w="12700">
+            <a:miter lim="400000"/>
+          </a:ln>
+        </p:spPr>
+      </p:pic>
+    </p:spTree>
+  </p:cSld>
+  <p:clrMapOvr>
+    <a:masterClrMapping/>
+  </p:clrMapOvr>
+  <p:transition xmlns:p14="http://schemas.microsoft.com/office/powerpoint/2010/main" spd="med" advClick="1"/>
+</p:sld>
+</file>
+
+<file path=ppt/slides/slide14.xml><?xml version="1.0" encoding="utf-8"?>
+<p:sld xmlns:a="http://schemas.openxmlformats.org/drawingml/2006/main" xmlns:r="http://schemas.openxmlformats.org/officeDocument/2006/relationships" xmlns:p="http://schemas.openxmlformats.org/presentationml/2006/main" xmlns:m="http://schemas.openxmlformats.org/officeDocument/2006/math" xmlns:a14="http://schemas.microsoft.com/office/drawing/2010/main" showMasterSp="1" showMasterPhAnim="1">
+  <p:cSld>
+    <p:spTree>
+      <p:nvGrpSpPr>
+        <p:cNvPr id="1" name=""/>
+        <p:cNvGrpSpPr/>
+        <p:nvPr/>
+      </p:nvGrpSpPr>
+      <p:grpSpPr>
+        <a:xfrm>
+          <a:off x="0" y="0"/>
+          <a:ext cx="0" cy="0"/>
+          <a:chOff x="0" y="0"/>
+          <a:chExt cx="0" cy="0"/>
+        </a:xfrm>
+      </p:grpSpPr>
+      <p:sp>
+        <p:nvSpPr>
+          <p:cNvPr id="147" name="Clarify: Multi-turn"/>
+          <p:cNvSpPr txBox="1"/>
+          <p:nvPr/>
+        </p:nvSpPr>
+        <p:spPr>
+          <a:xfrm>
+            <a:off x="262584" y="133732"/>
+            <a:ext cx="3150750" cy="789146"/>
+          </a:xfrm>
+          <a:prstGeom prst="rect">
+            <a:avLst/>
+          </a:prstGeom>
+          <a:ln w="12700">
+            <a:miter lim="400000"/>
+          </a:ln>
+          <a:extLst>
+            <a:ext uri="{C572A759-6A51-4108-AA02-DFA0A04FC94B}">
+              <ma14:wrappingTextBoxFlag xmlns:ma14="http://schemas.microsoft.com/office/mac/drawingml/2011/main" val="1"/>
+            </a:ext>
+          </a:extLst>
+        </p:spPr>
+        <p:txBody>
+          <a:bodyPr wrap="none" lIns="45718" tIns="45718" rIns="45718" bIns="45718">
+            <a:spAutoFit/>
+          </a:bodyPr>
+          <a:lstStyle/>
+          <a:p>
+            <a:pPr>
+              <a:defRPr>
+                <a:latin typeface="+mn-lt"/>
+                <a:ea typeface="+mn-ea"/>
+                <a:cs typeface="+mn-cs"/>
+                <a:sym typeface="Calibri"/>
+              </a:defRPr>
+            </a:pPr>
+          </a:p>
+          <a:p>
+            <a:pPr>
+              <a:defRPr b="1" sz="3200">
+                <a:latin typeface="+mn-lt"/>
+                <a:ea typeface="+mn-ea"/>
+                <a:cs typeface="+mn-cs"/>
+                <a:sym typeface="Calibri"/>
+              </a:defRPr>
+            </a:pPr>
+            <a:r>
+              <a:t>Clarify: Multi-turn</a:t>
+            </a:r>
+          </a:p>
+        </p:txBody>
+      </p:sp>
+      <p:pic>
+        <p:nvPicPr>
+          <p:cNvPr id="148" name="unknown.png" descr="unknown.png"/>
+          <p:cNvPicPr>
+            <a:picLocks noChangeAspect="1"/>
+          </p:cNvPicPr>
+          <p:nvPr/>
+        </p:nvPicPr>
+        <p:blipFill>
+          <a:blip r:embed="rId2">
+            <a:extLst/>
+          </a:blip>
+          <a:srcRect l="12322" t="19631" r="0" b="257"/>
+          <a:stretch>
+            <a:fillRect/>
+          </a:stretch>
+        </p:blipFill>
+        <p:spPr>
+          <a:xfrm>
+            <a:off x="108476" y="1296865"/>
+            <a:ext cx="8712983" cy="4104947"/>
+          </a:xfrm>
+          <a:prstGeom prst="rect">
+            <a:avLst/>
+          </a:prstGeom>
+          <a:ln w="12700">
+            <a:miter lim="400000"/>
+          </a:ln>
+        </p:spPr>
+      </p:pic>
+    </p:spTree>
+  </p:cSld>
+  <p:clrMapOvr>
+    <a:masterClrMapping/>
+  </p:clrMapOvr>
+  <p:transition xmlns:p14="http://schemas.microsoft.com/office/powerpoint/2010/main" spd="med" advClick="1"/>
+</p:sld>
+</file>
+
+<file path=ppt/slides/slide15.xml><?xml version="1.0" encoding="utf-8"?>
+<p:sld xmlns:a="http://schemas.openxmlformats.org/drawingml/2006/main" xmlns:r="http://schemas.openxmlformats.org/officeDocument/2006/relationships" xmlns:p="http://schemas.openxmlformats.org/presentationml/2006/main" xmlns:m="http://schemas.openxmlformats.org/officeDocument/2006/math" xmlns:a14="http://schemas.microsoft.com/office/drawing/2010/main" showMasterSp="1" showMasterPhAnim="1">
+  <p:cSld>
+    <p:bg>
+      <p:bgPr>
+        <a:solidFill>
+          <a:srgbClr val="F5F7FA"/>
+        </a:solidFill>
+      </p:bgPr>
+    </p:bg>
+    <p:spTree>
+      <p:nvGrpSpPr>
+        <p:cNvPr id="1" name=""/>
+        <p:cNvGrpSpPr/>
+        <p:nvPr/>
+      </p:nvGrpSpPr>
+      <p:grpSpPr>
+        <a:xfrm>
+          <a:off x="0" y="0"/>
+          <a:ext cx="0" cy="0"/>
+          <a:chOff x="0" y="0"/>
+          <a:chExt cx="0" cy="0"/>
+        </a:xfrm>
+      </p:grpSpPr>
+      <p:sp>
+        <p:nvSpPr>
+          <p:cNvPr id="150" name="Rectangle 1"/>
+          <p:cNvSpPr/>
+          <p:nvPr/>
+        </p:nvSpPr>
+        <p:spPr>
+          <a:xfrm>
+            <a:off x="0" y="-2"/>
+            <a:ext cx="9144000" cy="137164"/>
+          </a:xfrm>
+          <a:prstGeom prst="rect">
+            <a:avLst/>
+          </a:prstGeom>
+          <a:solidFill>
+            <a:srgbClr val="002060"/>
+          </a:solidFill>
+          <a:ln>
+            <a:solidFill>
+              <a:srgbClr val="002060"/>
+            </a:solidFill>
+          </a:ln>
+          <a:effectLst>
+            <a:outerShdw sx="100000" sy="100000" kx="0" ky="0" algn="b" rotWithShape="0" blurRad="38100" dist="23000" dir="5400000">
+              <a:srgbClr val="000000">
+                <a:alpha val="35000"/>
+              </a:srgbClr>
+            </a:outerShdw>
+          </a:effectLst>
+        </p:spPr>
+        <p:txBody>
+          <a:bodyPr lIns="45718" tIns="45718" rIns="45718" bIns="45718" anchor="ctr"/>
+          <a:lstStyle/>
+          <a:p>
+            <a:pPr algn="ctr">
+              <a:defRPr>
+                <a:solidFill>
+                  <a:srgbClr val="FFFFFF"/>
+                </a:solidFill>
+                <a:latin typeface="+mn-lt"/>
+                <a:ea typeface="+mn-ea"/>
+                <a:cs typeface="+mn-cs"/>
+                <a:sym typeface="Calibri"/>
+              </a:defRPr>
+            </a:pPr>
+          </a:p>
+        </p:txBody>
+      </p:sp>
+      <p:sp>
+        <p:nvSpPr>
+          <p:cNvPr id="151" name="TextBox 2"/>
+          <p:cNvSpPr txBox="1"/>
+          <p:nvPr/>
+        </p:nvSpPr>
+        <p:spPr>
+          <a:xfrm>
+            <a:off x="502919" y="182879"/>
+            <a:ext cx="6788109" cy="789146"/>
+          </a:xfrm>
+          <a:prstGeom prst="rect">
+            <a:avLst/>
+          </a:prstGeom>
+          <a:ln w="12700">
+            <a:miter lim="400000"/>
+          </a:ln>
+          <a:extLst>
+            <a:ext uri="{C572A759-6A51-4108-AA02-DFA0A04FC94B}">
+              <ma14:wrappingTextBoxFlag xmlns:ma14="http://schemas.microsoft.com/office/mac/drawingml/2011/main" val="1"/>
+            </a:ext>
+          </a:extLst>
+        </p:spPr>
+        <p:txBody>
+          <a:bodyPr wrap="none" lIns="45718" tIns="45718" rIns="45718" bIns="45718">
+            <a:spAutoFit/>
+          </a:bodyPr>
+          <a:lstStyle/>
+          <a:p>
+            <a:pPr>
+              <a:defRPr>
+                <a:latin typeface="+mn-lt"/>
+                <a:ea typeface="+mn-ea"/>
+                <a:cs typeface="+mn-cs"/>
+                <a:sym typeface="Calibri"/>
+              </a:defRPr>
+            </a:pPr>
+          </a:p>
+          <a:p>
+            <a:pPr>
+              <a:defRPr b="1" sz="3200">
+                <a:latin typeface="+mn-lt"/>
+                <a:ea typeface="+mn-ea"/>
+                <a:cs typeface="+mn-cs"/>
+                <a:sym typeface="Calibri"/>
+              </a:defRPr>
+            </a:pPr>
+            <a:r>
+              <a:t>3. Context Verification with Verify Node</a:t>
+            </a:r>
+          </a:p>
+        </p:txBody>
+      </p:sp>
+      <p:pic>
+        <p:nvPicPr>
+          <p:cNvPr id="152" name="pasted-movie.png" descr="pasted-movie.png"/>
           <p:cNvPicPr>
             <a:picLocks noChangeAspect="1"/>
           </p:cNvPicPr>
@@ -3576,7 +3779,7 @@
         <p:spPr>
           <a:xfrm>
             <a:off x="33337" y="1857354"/>
-            <a:ext cx="9077265" cy="2819550"/>
+            <a:ext cx="9077266" cy="2819551"/>
           </a:xfrm>
           <a:prstGeom prst="rect">
             <a:avLst/>
@@ -3628,22 +3831,21 @@
           </p:nvPr>
         </p:nvSpPr>
         <p:spPr>
+          <a:xfrm>
+            <a:off x="457200" y="274638"/>
+            <a:ext cx="8229600" cy="1143001"/>
+          </a:xfrm>
           <a:prstGeom prst="rect">
             <a:avLst/>
           </a:prstGeom>
         </p:spPr>
         <p:txBody>
           <a:bodyPr/>
-          <a:lstStyle>
-            <a:lvl1pPr defTabSz="393192">
-              <a:defRPr sz="3784"/>
-            </a:lvl1pPr>
-          </a:lstStyle>
-          <a:p>
-            <a:pPr/>
-            <a:r>
-              <a:t>The Problem: Vector Search Lacks Set Theory</a:t>
-            </a:r>
+          <a:lstStyle/>
+          <a:p>
+            <a:pPr defTabSz="393191">
+              <a:defRPr sz="3700"/>
+            </a:pPr>
           </a:p>
         </p:txBody>
       </p:sp>
@@ -3672,29 +3874,29 @@
               <a:spcBef>
                 <a:spcPts val="500"/>
               </a:spcBef>
-              <a:defRPr sz="2496"/>
+              <a:defRPr sz="2400"/>
             </a:pPr>
             <a:r>
               <a:t>The Core Vulnerability of Standard RAG:</a:t>
             </a:r>
           </a:p>
           <a:p>
-            <a:pPr lvl="1" marL="579500" indent="-222884" defTabSz="356615">
+            <a:pPr lvl="1" marL="579499" indent="-222883" defTabSz="356615">
               <a:spcBef>
                 <a:spcPts val="500"/>
               </a:spcBef>
-              <a:defRPr sz="2184"/>
+              <a:defRPr sz="2100"/>
             </a:pPr>
             <a:r>
               <a:t>Standard vector DBs cannot reliably execute hard constraints (e.g., 'only 2023 filings').</a:t>
             </a:r>
           </a:p>
           <a:p>
-            <a:pPr lvl="1" marL="579500" indent="-222884" defTabSz="356615">
+            <a:pPr lvl="1" marL="579499" indent="-222883" defTabSz="356615">
               <a:spcBef>
                 <a:spcPts val="500"/>
               </a:spcBef>
-              <a:defRPr sz="2184"/>
+              <a:defRPr sz="2100"/>
             </a:pPr>
             <a:r>
               <a:t>Result: Vector drift. The model silently mixes temporal context across different years or corporate entities.</a:t>
@@ -3705,40 +3907,40 @@
               <a:spcBef>
                 <a:spcPts val="500"/>
               </a:spcBef>
-              <a:defRPr sz="2496"/>
+              <a:defRPr sz="2400"/>
             </a:pPr>
             <a:r>
               <a:t>Our Architectural Solution:</a:t>
             </a:r>
           </a:p>
           <a:p>
-            <a:pPr lvl="1" marL="579500" indent="-222884" defTabSz="356615">
+            <a:pPr lvl="1" marL="579499" indent="-222883" defTabSz="356615">
               <a:spcBef>
                 <a:spcPts val="500"/>
               </a:spcBef>
-              <a:defRPr sz="2184"/>
+              <a:defRPr sz="2100"/>
             </a:pPr>
             <a:r>
               <a:t>Decouple strict metadata filtering from the semantic search engine.</a:t>
             </a:r>
           </a:p>
           <a:p>
-            <a:pPr lvl="1" marL="579500" indent="-222884" defTabSz="356615">
+            <a:pPr lvl="1" marL="579499" indent="-222883" defTabSz="356615">
               <a:spcBef>
                 <a:spcPts val="500"/>
               </a:spcBef>
-              <a:defRPr sz="2184"/>
+              <a:defRPr sz="2100"/>
             </a:pPr>
             <a:r>
               <a:t>Replace open-ended ReAct LLM loops with a deterministic state machine.</a:t>
             </a:r>
           </a:p>
           <a:p>
-            <a:pPr lvl="1" marL="579500" indent="-222884" defTabSz="356615">
+            <a:pPr lvl="1" marL="579499" indent="-222883" defTabSz="356615">
               <a:spcBef>
                 <a:spcPts val="500"/>
               </a:spcBef>
-              <a:defRPr sz="2184"/>
+              <a:defRPr sz="2100"/>
             </a:pPr>
             <a:r>
               <a:t>Enforce fail-fast SQL checks before executing expensive embedding calls.</a:t>
@@ -3754,8 +3956,8 @@
         </p:nvSpPr>
         <p:spPr>
           <a:xfrm>
-            <a:off x="0" y="-1"/>
-            <a:ext cx="9144000" cy="137162"/>
+            <a:off x="0" y="-2"/>
+            <a:ext cx="9144000" cy="137164"/>
           </a:xfrm>
           <a:prstGeom prst="rect">
             <a:avLst/>
@@ -3777,7 +3979,7 @@
           </a:effectLst>
         </p:spPr>
         <p:txBody>
-          <a:bodyPr lIns="45719" rIns="45719" anchor="ctr"/>
+          <a:bodyPr lIns="45718" tIns="45718" rIns="45718" bIns="45718" anchor="ctr"/>
           <a:lstStyle/>
           <a:p>
             <a:pPr algn="ctr">
@@ -3785,6 +3987,10 @@
                 <a:solidFill>
                   <a:srgbClr val="FFFFFF"/>
                 </a:solidFill>
+                <a:latin typeface="+mn-lt"/>
+                <a:ea typeface="+mn-ea"/>
+                <a:cs typeface="+mn-cs"/>
+                <a:sym typeface="Calibri"/>
               </a:defRPr>
             </a:pPr>
           </a:p>
@@ -3832,6 +4038,10 @@
           </p:nvPr>
         </p:nvSpPr>
         <p:spPr>
+          <a:xfrm>
+            <a:off x="457200" y="274638"/>
+            <a:ext cx="8229600" cy="1143001"/>
+          </a:xfrm>
           <a:prstGeom prst="rect">
             <a:avLst/>
           </a:prstGeom>
@@ -3839,14 +4049,14 @@
         <p:txBody>
           <a:bodyPr/>
           <a:lstStyle>
-            <a:lvl1pPr defTabSz="438911">
-              <a:defRPr sz="4224"/>
+            <a:lvl1pPr defTabSz="434521">
+              <a:defRPr sz="4158"/>
             </a:lvl1pPr>
           </a:lstStyle>
           <a:p>
             <a:pPr/>
             <a:r>
-              <a:t>Decoupled Storage &amp; Union Retrieval</a:t>
+              <a:t>Decoupled Storage &amp; Hybrid Retrieval</a:t>
             </a:r>
           </a:p>
         </p:txBody>
@@ -3872,91 +4082,113 @@
           <a:bodyPr/>
           <a:lstStyle/>
           <a:p>
-            <a:pPr marL="267461" indent="-267461" defTabSz="356615">
-              <a:spcBef>
-                <a:spcPts val="500"/>
-              </a:spcBef>
-              <a:defRPr sz="2496"/>
+            <a:pPr marL="243389" indent="-243389" defTabSz="324519">
+              <a:spcBef>
+                <a:spcPts val="400"/>
+              </a:spcBef>
+              <a:defRPr sz="2184"/>
             </a:pPr>
             <a:r>
               <a:t>DuckDB (In-Process SQL) -&gt; The Catalog</a:t>
             </a:r>
           </a:p>
           <a:p>
-            <a:pPr lvl="1" marL="579500" indent="-222884" defTabSz="356615">
-              <a:spcBef>
-                <a:spcPts val="500"/>
+            <a:pPr lvl="1" marL="527344" indent="-202824" defTabSz="324519">
+              <a:spcBef>
+                <a:spcPts val="400"/>
+              </a:spcBef>
+              <a:defRPr sz="1911"/>
+            </a:pPr>
+            <a:r>
+              <a:t>Handles exact metadata filters and target validation in &lt;5ms.</a:t>
+            </a:r>
+          </a:p>
+          <a:p>
+            <a:pPr marL="243389" indent="-243389" defTabSz="324519">
+              <a:spcBef>
+                <a:spcPts val="400"/>
               </a:spcBef>
               <a:defRPr sz="2184"/>
             </a:pPr>
             <a:r>
-              <a:t>Handles exact metadata filters and target validation in &lt;5ms.</a:t>
-            </a:r>
-          </a:p>
-          <a:p>
-            <a:pPr marL="267461" indent="-267461" defTabSz="356615">
-              <a:spcBef>
-                <a:spcPts val="500"/>
-              </a:spcBef>
-              <a:defRPr sz="2496"/>
-            </a:pPr>
-            <a:r>
               <a:t>FAISS (Dense) + BM25 (Sparse) -&gt; The Search</a:t>
             </a:r>
           </a:p>
           <a:p>
-            <a:pPr lvl="1" marL="579500" indent="-222884" defTabSz="356615">
-              <a:spcBef>
-                <a:spcPts val="500"/>
+            <a:pPr lvl="1" marL="527344" indent="-202824" defTabSz="324519">
+              <a:spcBef>
+                <a:spcPts val="400"/>
+              </a:spcBef>
+              <a:defRPr sz="1911"/>
+            </a:pPr>
+            <a:r>
+              <a:t>Dense catches semantic intent; Sparse catches exact tickers and section codes.</a:t>
+            </a:r>
+          </a:p>
+          <a:p>
+            <a:pPr marL="243389" indent="-243389" defTabSz="324519">
+              <a:spcBef>
+                <a:spcPts val="400"/>
               </a:spcBef>
               <a:defRPr sz="2184"/>
             </a:pPr>
             <a:r>
-              <a:t>Dense catches semantic intent; Sparse catches exact tickers and section codes.</a:t>
-            </a:r>
-          </a:p>
-          <a:p>
-            <a:pPr marL="267461" indent="-267461" defTabSz="356615">
-              <a:spcBef>
-                <a:spcPts val="500"/>
-              </a:spcBef>
-              <a:defRPr sz="2496"/>
-            </a:pPr>
-            <a:r>
               <a:t>Why we reject RRF (Reciprocal Rank Fusion):</a:t>
             </a:r>
           </a:p>
           <a:p>
-            <a:pPr lvl="1" marL="579500" indent="-222884" defTabSz="356615">
-              <a:spcBef>
-                <a:spcPts val="500"/>
+            <a:pPr lvl="1" marL="527344" indent="-202824" defTabSz="324519">
+              <a:spcBef>
+                <a:spcPts val="400"/>
+              </a:spcBef>
+              <a:defRPr sz="1911"/>
+            </a:pPr>
+            <a:r>
+              <a:t>RRF relies on arbitrary rank math. Instead, we union candidate IDs to guarantee we never drop a perfect keyword match.</a:t>
+            </a:r>
+          </a:p>
+          <a:p>
+            <a:pPr marL="243389" indent="-243389" defTabSz="324519">
+              <a:spcBef>
+                <a:spcPts val="400"/>
               </a:spcBef>
               <a:defRPr sz="2184"/>
             </a:pPr>
             <a:r>
-              <a:t>RRF relies on arbitrary rank math. Instead, we union candidate IDs to guarantee we never drop a perfect keyword match.</a:t>
-            </a:r>
-          </a:p>
-          <a:p>
-            <a:pPr marL="267461" indent="-267461" defTabSz="356615">
-              <a:spcBef>
-                <a:spcPts val="500"/>
-              </a:spcBef>
-              <a:defRPr sz="2496"/>
-            </a:pPr>
-            <a:r>
               <a:t>Cross-Encoder (Reranker) -&gt; The Filter</a:t>
             </a:r>
           </a:p>
           <a:p>
-            <a:pPr lvl="1" marL="579500" indent="-222884" defTabSz="356615">
-              <a:spcBef>
-                <a:spcPts val="500"/>
-              </a:spcBef>
-              <a:defRPr sz="2184"/>
-            </a:pPr>
-            <a:r>
-              <a:t>Evaluates the bounded union set jointly (query + passage) for highest precision before sending context to the LLM.</a:t>
+            <a:pPr lvl="1" marL="527344" indent="-202824" defTabSz="324519">
+              <a:spcBef>
+                <a:spcPts val="400"/>
+              </a:spcBef>
+              <a:defRPr sz="1911"/>
+            </a:pPr>
+            <a:r>
+              <a:t>Evaluates the hybrid  union set jointly (query + passage) for highest precision before sending context to the LLM.</a:t>
+            </a:r>
+          </a:p>
+          <a:p>
+            <a:pPr lvl="1" marL="527344" indent="-202824" defTabSz="324519">
+              <a:spcBef>
+                <a:spcPts val="400"/>
+              </a:spcBef>
+              <a:defRPr sz="1911"/>
+            </a:pPr>
+            <a:r>
+              <a:t>Reranks the hybrid union for better answer quality.</a:t>
+            </a:r>
+          </a:p>
+          <a:p>
+            <a:pPr lvl="1" marL="527344" indent="-202824" defTabSz="324519">
+              <a:spcBef>
+                <a:spcPts val="400"/>
+              </a:spcBef>
+              <a:defRPr sz="1911"/>
+            </a:pPr>
+            <a:r>
+              <a:t>Compares the retrieved docs directly with the query.</a:t>
             </a:r>
           </a:p>
         </p:txBody>
@@ -3969,8 +4201,8 @@
         </p:nvSpPr>
         <p:spPr>
           <a:xfrm>
-            <a:off x="0" y="-1"/>
-            <a:ext cx="9144000" cy="137162"/>
+            <a:off x="0" y="-2"/>
+            <a:ext cx="9144000" cy="137164"/>
           </a:xfrm>
           <a:prstGeom prst="rect">
             <a:avLst/>
@@ -3992,7 +4224,7 @@
           </a:effectLst>
         </p:spPr>
         <p:txBody>
-          <a:bodyPr lIns="45719" rIns="45719" anchor="ctr"/>
+          <a:bodyPr lIns="45718" tIns="45718" rIns="45718" bIns="45718" anchor="ctr"/>
           <a:lstStyle/>
           <a:p>
             <a:pPr algn="ctr">
@@ -4000,6 +4232,10 @@
                 <a:solidFill>
                   <a:srgbClr val="FFFFFF"/>
                 </a:solidFill>
+                <a:latin typeface="+mn-lt"/>
+                <a:ea typeface="+mn-ea"/>
+                <a:cs typeface="+mn-cs"/>
+                <a:sym typeface="Calibri"/>
               </a:defRPr>
             </a:pPr>
           </a:p>
@@ -4047,6 +4283,10 @@
           </p:nvPr>
         </p:nvSpPr>
         <p:spPr>
+          <a:xfrm>
+            <a:off x="457200" y="274638"/>
+            <a:ext cx="8229600" cy="1143001"/>
+          </a:xfrm>
           <a:prstGeom prst="rect">
             <a:avLst/>
           </a:prstGeom>
@@ -4054,8 +4294,8 @@
         <p:txBody>
           <a:bodyPr/>
           <a:lstStyle>
-            <a:lvl1pPr defTabSz="393192">
-              <a:defRPr sz="3784"/>
+            <a:lvl1pPr defTabSz="393191">
+              <a:defRPr sz="3700"/>
             </a:lvl1pPr>
           </a:lstStyle>
           <a:p>
@@ -4091,7 +4331,7 @@
               <a:spcBef>
                 <a:spcPts val="600"/>
               </a:spcBef>
-              <a:defRPr sz="2784"/>
+              <a:defRPr sz="2700"/>
             </a:pPr>
             <a:r>
               <a:t>Why LangGraph over standard Chaining?</a:t>
@@ -4102,7 +4342,7 @@
               <a:spcBef>
                 <a:spcPts val="500"/>
               </a:spcBef>
-              <a:defRPr sz="2436"/>
+              <a:defRPr sz="2400"/>
             </a:pPr>
             <a:r>
               <a:t>Financial workflows require full state visibility and explicit loop control, avoiding stochastic LLM routing.</a:t>
@@ -4113,7 +4353,7 @@
               <a:spcBef>
                 <a:spcPts val="600"/>
               </a:spcBef>
-              <a:defRPr sz="2784"/>
+              <a:defRPr sz="2700"/>
             </a:pPr>
             <a:r>
               <a:t>Strict State Typing with Pydantic:</a:t>
@@ -4124,7 +4364,7 @@
               <a:spcBef>
                 <a:spcPts val="500"/>
               </a:spcBef>
-              <a:defRPr sz="2436"/>
+              <a:defRPr sz="2400"/>
             </a:pPr>
             <a:r>
               <a:t>The graph's state object is strongly typed via Pydantic.</a:t>
@@ -4135,7 +4375,7 @@
               <a:spcBef>
                 <a:spcPts val="500"/>
               </a:spcBef>
-              <a:defRPr sz="2436"/>
+              <a:defRPr sz="2400"/>
             </a:pPr>
             <a:r>
               <a:t>Guarantees schema validation across node transitions, ensuring predictable data mutation.</a:t>
@@ -4146,7 +4386,7 @@
               <a:spcBef>
                 <a:spcPts val="600"/>
               </a:spcBef>
-              <a:defRPr sz="2784"/>
+              <a:defRPr sz="2700"/>
             </a:pPr>
             <a:r>
               <a:t>State Persistence (Checkpointing):</a:t>
@@ -4157,7 +4397,7 @@
               <a:spcBef>
                 <a:spcPts val="500"/>
               </a:spcBef>
-              <a:defRPr sz="2436"/>
+              <a:defRPr sz="2400"/>
             </a:pPr>
             <a:r>
               <a:t>State is persisted via thread_id, allowing the graph to safely pause (interrupt) for user input without context loss.</a:t>
@@ -4173,8 +4413,8 @@
         </p:nvSpPr>
         <p:spPr>
           <a:xfrm>
-            <a:off x="0" y="-1"/>
-            <a:ext cx="9144000" cy="137162"/>
+            <a:off x="0" y="-2"/>
+            <a:ext cx="9144000" cy="137164"/>
           </a:xfrm>
           <a:prstGeom prst="rect">
             <a:avLst/>
@@ -4196,7 +4436,7 @@
           </a:effectLst>
         </p:spPr>
         <p:txBody>
-          <a:bodyPr lIns="45719" rIns="45719" anchor="ctr"/>
+          <a:bodyPr lIns="45718" tIns="45718" rIns="45718" bIns="45718" anchor="ctr"/>
           <a:lstStyle/>
           <a:p>
             <a:pPr algn="ctr">
@@ -4204,6 +4444,10 @@
                 <a:solidFill>
                   <a:srgbClr val="FFFFFF"/>
                 </a:solidFill>
+                <a:latin typeface="+mn-lt"/>
+                <a:ea typeface="+mn-ea"/>
+                <a:cs typeface="+mn-cs"/>
+                <a:sym typeface="Calibri"/>
               </a:defRPr>
             </a:pPr>
           </a:p>
@@ -4250,8 +4494,8 @@
         </p:nvSpPr>
         <p:spPr>
           <a:xfrm>
-            <a:off x="0" y="-1"/>
-            <a:ext cx="9144000" cy="137162"/>
+            <a:off x="0" y="-2"/>
+            <a:ext cx="9144000" cy="137164"/>
           </a:xfrm>
           <a:prstGeom prst="rect">
             <a:avLst/>
@@ -4273,7 +4517,7 @@
           </a:effectLst>
         </p:spPr>
         <p:txBody>
-          <a:bodyPr lIns="45719" rIns="45719" anchor="ctr"/>
+          <a:bodyPr lIns="45718" tIns="45718" rIns="45718" bIns="45718" anchor="ctr"/>
           <a:lstStyle/>
           <a:p>
             <a:pPr algn="ctr">
@@ -4281,6 +4525,10 @@
                 <a:solidFill>
                   <a:srgbClr val="FFFFFF"/>
                 </a:solidFill>
+                <a:latin typeface="+mn-lt"/>
+                <a:ea typeface="+mn-ea"/>
+                <a:cs typeface="+mn-cs"/>
+                <a:sym typeface="Calibri"/>
               </a:defRPr>
             </a:pPr>
           </a:p>
@@ -4295,7 +4543,7 @@
         <p:spPr>
           <a:xfrm>
             <a:off x="502919" y="182879"/>
-            <a:ext cx="6596223" cy="789148"/>
+            <a:ext cx="6596220" cy="789146"/>
           </a:xfrm>
           <a:prstGeom prst="rect">
             <a:avLst/>
@@ -4310,26 +4558,172 @@
           </a:extLst>
         </p:spPr>
         <p:txBody>
-          <a:bodyPr wrap="none" lIns="45719" rIns="45719">
+          <a:bodyPr wrap="none" lIns="45718" tIns="45718" rIns="45718" bIns="45718">
             <a:spAutoFit/>
           </a:bodyPr>
           <a:lstStyle/>
           <a:p>
-            <a:pPr/>
-          </a:p>
-          <a:p>
             <a:pPr>
-              <a:defRPr b="1" sz="3200"/>
+              <a:defRPr>
+                <a:latin typeface="+mn-lt"/>
+                <a:ea typeface="+mn-ea"/>
+                <a:cs typeface="+mn-cs"/>
+                <a:sym typeface="Calibri"/>
+              </a:defRPr>
+            </a:pPr>
+          </a:p>
+          <a:p>
+            <a:pPr>
+              <a:defRPr b="1" sz="3200">
+                <a:latin typeface="+mn-lt"/>
+                <a:ea typeface="+mn-ea"/>
+                <a:cs typeface="+mn-cs"/>
+                <a:sym typeface="Calibri"/>
+              </a:defRPr>
             </a:pPr>
             <a:r>
               <a:t>Agent Node Strategy &amp; Execution Flow</a:t>
             </a:r>
+          </a:p>
+        </p:txBody>
+      </p:sp>
+      <p:sp>
+        <p:nvSpPr>
+          <p:cNvPr id="112" name="TextBox 4"/>
+          <p:cNvSpPr txBox="1"/>
+          <p:nvPr/>
+        </p:nvSpPr>
+        <p:spPr>
+          <a:xfrm>
+            <a:off x="5779666" y="1381818"/>
+            <a:ext cx="3108962" cy="3976498"/>
+          </a:xfrm>
+          <a:prstGeom prst="rect">
+            <a:avLst/>
+          </a:prstGeom>
+          <a:ln w="12700">
+            <a:miter lim="400000"/>
+          </a:ln>
+          <a:extLst>
+            <a:ext uri="{C572A759-6A51-4108-AA02-DFA0A04FC94B}">
+              <ma14:wrappingTextBoxFlag xmlns:ma14="http://schemas.microsoft.com/office/mac/drawingml/2011/main" val="1"/>
+            </a:ext>
+          </a:extLst>
+        </p:spPr>
+        <p:txBody>
+          <a:bodyPr lIns="45718" tIns="45718" rIns="45718" bIns="45718">
+            <a:spAutoFit/>
+          </a:bodyPr>
+          <a:lstStyle/>
+          <a:p>
+            <a:pPr>
+              <a:defRPr>
+                <a:latin typeface="+mn-lt"/>
+                <a:ea typeface="+mn-ea"/>
+                <a:cs typeface="+mn-cs"/>
+                <a:sym typeface="Calibri"/>
+              </a:defRPr>
+            </a:pPr>
+          </a:p>
+          <a:p>
+            <a:pPr>
+              <a:defRPr b="1" sz="1600">
+                <a:latin typeface="+mn-lt"/>
+                <a:ea typeface="+mn-ea"/>
+                <a:cs typeface="+mn-cs"/>
+                <a:sym typeface="Calibri"/>
+              </a:defRPr>
+            </a:pPr>
+            <a:r>
+              <a:t>Small LLM First Strategy:</a:t>
+            </a:r>
+          </a:p>
+          <a:p>
+            <a:pPr>
+              <a:defRPr sz="1400">
+                <a:latin typeface="+mn-lt"/>
+                <a:ea typeface="+mn-ea"/>
+                <a:cs typeface="+mn-cs"/>
+                <a:sym typeface="Calibri"/>
+              </a:defRPr>
+            </a:pPr>
+            <a:r>
+              <a:t>The Planner uses a fast, low-parameter model purely for structured entity extraction (Company, Year).</a:t>
+            </a:r>
+          </a:p>
+          <a:p>
+            <a:pPr>
+              <a:spcBef>
+                <a:spcPts val="1400"/>
+              </a:spcBef>
+              <a:defRPr b="1" sz="1600">
+                <a:latin typeface="+mn-lt"/>
+                <a:ea typeface="+mn-ea"/>
+                <a:cs typeface="+mn-cs"/>
+                <a:sym typeface="Calibri"/>
+              </a:defRPr>
+            </a:pPr>
+            <a:r>
+              <a:t>Reserve Large Models:</a:t>
+            </a:r>
+          </a:p>
+          <a:p>
+            <a:pPr>
+              <a:defRPr sz="1400">
+                <a:latin typeface="+mn-lt"/>
+                <a:ea typeface="+mn-ea"/>
+                <a:cs typeface="+mn-cs"/>
+                <a:sym typeface="Calibri"/>
+              </a:defRPr>
+            </a:pPr>
+            <a:r>
+              <a:t>Only the final Answer node uses an expensive reasoning model, minimizing token cost and latency.</a:t>
+            </a:r>
+          </a:p>
+          <a:p>
+            <a:pPr>
+              <a:spcBef>
+                <a:spcPts val="1400"/>
+              </a:spcBef>
+              <a:defRPr b="1" sz="1600">
+                <a:latin typeface="+mn-lt"/>
+                <a:ea typeface="+mn-ea"/>
+                <a:cs typeface="+mn-cs"/>
+                <a:sym typeface="Calibri"/>
+              </a:defRPr>
+            </a:pPr>
+            <a:r>
+              <a:t>Single-Responsibility Nodes:</a:t>
+            </a:r>
+          </a:p>
+          <a:p>
+            <a:pPr>
+              <a:defRPr sz="1400">
+                <a:latin typeface="+mn-lt"/>
+                <a:ea typeface="+mn-ea"/>
+                <a:cs typeface="+mn-cs"/>
+                <a:sym typeface="Calibri"/>
+              </a:defRPr>
+            </a:pPr>
+            <a:r>
+              <a:t>Each node executes one explicit task. Edges are controlled by Python logic, not LLM guesses</a:t>
+            </a:r>
+          </a:p>
+          <a:p>
+            <a:pPr>
+              <a:defRPr sz="1400">
+                <a:latin typeface="+mn-lt"/>
+                <a:ea typeface="+mn-ea"/>
+                <a:cs typeface="+mn-cs"/>
+                <a:sym typeface="Calibri"/>
+              </a:defRPr>
+            </a:pPr>
           </a:p>
         </p:txBody>
       </p:sp>
       <p:pic>
         <p:nvPicPr>
-          <p:cNvPr id="112" name="Picture 3" descr="Picture 3"/>
+          <p:cNvPr id="113" name="pasted-movie.png" descr="pasted-movie.png"/>
           <p:cNvPicPr>
             <a:picLocks noChangeAspect="1"/>
           </p:cNvPicPr>
@@ -4345,8 +4739,8 @@
         </p:blipFill>
         <p:spPr>
           <a:xfrm>
-            <a:off x="457200" y="1097280"/>
-            <a:ext cx="5029200" cy="2995508"/>
+            <a:off x="226147" y="1269540"/>
+            <a:ext cx="5487083" cy="4318920"/>
           </a:xfrm>
           <a:prstGeom prst="rect">
             <a:avLst/>
@@ -4356,93 +4750,6 @@
           </a:ln>
         </p:spPr>
       </p:pic>
-      <p:sp>
-        <p:nvSpPr>
-          <p:cNvPr id="113" name="TextBox 4"/>
-          <p:cNvSpPr txBox="1"/>
-          <p:nvPr/>
-        </p:nvSpPr>
-        <p:spPr>
-          <a:xfrm>
-            <a:off x="5714999" y="1097280"/>
-            <a:ext cx="3108961" cy="3519300"/>
-          </a:xfrm>
-          <a:prstGeom prst="rect">
-            <a:avLst/>
-          </a:prstGeom>
-          <a:ln w="12700">
-            <a:miter lim="400000"/>
-          </a:ln>
-          <a:extLst>
-            <a:ext uri="{C572A759-6A51-4108-AA02-DFA0A04FC94B}">
-              <ma14:wrappingTextBoxFlag xmlns:ma14="http://schemas.microsoft.com/office/mac/drawingml/2011/main" val="1"/>
-            </a:ext>
-          </a:extLst>
-        </p:spPr>
-        <p:txBody>
-          <a:bodyPr lIns="45719" rIns="45719">
-            <a:spAutoFit/>
-          </a:bodyPr>
-          <a:lstStyle/>
-          <a:p>
-            <a:pPr/>
-          </a:p>
-          <a:p>
-            <a:pPr>
-              <a:defRPr b="1" sz="1600"/>
-            </a:pPr>
-            <a:r>
-              <a:t>Small LLM First Strategy:</a:t>
-            </a:r>
-          </a:p>
-          <a:p>
-            <a:pPr>
-              <a:defRPr sz="1400"/>
-            </a:pPr>
-            <a:r>
-              <a:t>The Planner uses a fast, low-parameter model purely for structured entity extraction (Company, Year).</a:t>
-            </a:r>
-          </a:p>
-          <a:p>
-            <a:pPr>
-              <a:spcBef>
-                <a:spcPts val="1400"/>
-              </a:spcBef>
-              <a:defRPr b="1" sz="1600"/>
-            </a:pPr>
-            <a:r>
-              <a:t>Reserve Large Models:</a:t>
-            </a:r>
-          </a:p>
-          <a:p>
-            <a:pPr>
-              <a:defRPr sz="1400"/>
-            </a:pPr>
-            <a:r>
-              <a:t>Only the final Answer node uses an expensive reasoning model, minimizing token cost and latency.</a:t>
-            </a:r>
-          </a:p>
-          <a:p>
-            <a:pPr>
-              <a:spcBef>
-                <a:spcPts val="1400"/>
-              </a:spcBef>
-              <a:defRPr b="1" sz="1600"/>
-            </a:pPr>
-            <a:r>
-              <a:t>Single-Responsibility Nodes:</a:t>
-            </a:r>
-          </a:p>
-          <a:p>
-            <a:pPr>
-              <a:defRPr sz="1400"/>
-            </a:pPr>
-            <a:r>
-              <a:t>Each node executes one explicit task. Edges are controlled by Python logic, not LLM guesses.</a:t>
-            </a:r>
-          </a:p>
-        </p:txBody>
-      </p:sp>
     </p:spTree>
   </p:cSld>
   <p:clrMapOvr>
@@ -4485,6 +4792,10 @@
           </p:nvPr>
         </p:nvSpPr>
         <p:spPr>
+          <a:xfrm>
+            <a:off x="457200" y="274638"/>
+            <a:ext cx="8229600" cy="1143001"/>
+          </a:xfrm>
           <a:prstGeom prst="rect">
             <a:avLst/>
           </a:prstGeom>
@@ -4492,8 +4803,8 @@
         <p:txBody>
           <a:bodyPr/>
           <a:lstStyle>
-            <a:lvl1pPr defTabSz="393192">
-              <a:defRPr sz="3784"/>
+            <a:lvl1pPr defTabSz="393191">
+              <a:defRPr sz="3700"/>
             </a:lvl1pPr>
           </a:lstStyle>
           <a:p>
@@ -4525,77 +4836,77 @@
           <a:bodyPr/>
           <a:lstStyle/>
           <a:p>
-            <a:pPr marL="305180" indent="-305180" defTabSz="406908">
+            <a:pPr marL="305179" indent="-305179" defTabSz="406908">
               <a:spcBef>
                 <a:spcPts val="600"/>
               </a:spcBef>
-              <a:defRPr sz="2848"/>
+              <a:defRPr sz="2800"/>
             </a:pPr>
             <a:r>
               <a:t>Why SQL First? (Zero Hallucination Routing)</a:t>
             </a:r>
           </a:p>
           <a:p>
-            <a:pPr lvl="1" marL="661225" indent="-254317" defTabSz="406908">
+            <a:pPr lvl="1" marL="661224" indent="-254316" defTabSz="406908">
               <a:spcBef>
                 <a:spcPts val="500"/>
               </a:spcBef>
-              <a:defRPr sz="2492"/>
+              <a:defRPr sz="2400"/>
             </a:pPr>
             <a:r>
               <a:t>By executing SQL against DuckDB first, we filter the allowed candidate set before touching vectors.</a:t>
             </a:r>
           </a:p>
           <a:p>
-            <a:pPr lvl="1" marL="661225" indent="-254317" defTabSz="406908">
+            <a:pPr lvl="1" marL="661224" indent="-254316" defTabSz="406908">
               <a:spcBef>
                 <a:spcPts val="500"/>
               </a:spcBef>
-              <a:defRPr sz="2492"/>
+              <a:defRPr sz="2400"/>
             </a:pPr>
             <a:r>
               <a:t>Mathematically eliminates the LLM hallucinating data from the wrong company.</a:t>
             </a:r>
           </a:p>
           <a:p>
-            <a:pPr marL="305180" indent="-305180" defTabSz="406908">
+            <a:pPr marL="305179" indent="-305179" defTabSz="406908">
               <a:spcBef>
                 <a:spcPts val="600"/>
               </a:spcBef>
-              <a:defRPr sz="2848"/>
+              <a:defRPr sz="2800"/>
             </a:pPr>
             <a:r>
               <a:t>The 0, 1, &gt;1 Rule:</a:t>
             </a:r>
           </a:p>
           <a:p>
-            <a:pPr lvl="1" marL="661225" indent="-254317" defTabSz="406908">
+            <a:pPr lvl="1" marL="661224" indent="-254316" defTabSz="406908">
               <a:spcBef>
                 <a:spcPts val="500"/>
               </a:spcBef>
-              <a:defRPr sz="2492"/>
+              <a:defRPr sz="2400"/>
             </a:pPr>
             <a:r>
               <a:t>0 Matches -&gt; Halt execution. Target not in corpus.</a:t>
             </a:r>
           </a:p>
           <a:p>
-            <a:pPr lvl="1" marL="661225" indent="-254317" defTabSz="406908">
+            <a:pPr lvl="1" marL="661224" indent="-254316" defTabSz="406908">
               <a:spcBef>
                 <a:spcPts val="500"/>
               </a:spcBef>
-              <a:defRPr sz="2492"/>
+              <a:defRPr sz="2400"/>
             </a:pPr>
             <a:r>
               <a:t>1 Match -&gt; Exact target resolved. Proceed silently.</a:t>
             </a:r>
           </a:p>
           <a:p>
-            <a:pPr lvl="1" marL="661225" indent="-254317" defTabSz="406908">
+            <a:pPr lvl="1" marL="661224" indent="-254316" defTabSz="406908">
               <a:spcBef>
                 <a:spcPts val="500"/>
               </a:spcBef>
-              <a:defRPr sz="2492"/>
+              <a:defRPr sz="2400"/>
             </a:pPr>
             <a:r>
               <a:t>&gt; 1 Match -&gt; Interrupt. Force user to clarify based on exact database options.</a:t>
@@ -4611,8 +4922,8 @@
         </p:nvSpPr>
         <p:spPr>
           <a:xfrm>
-            <a:off x="0" y="-1"/>
-            <a:ext cx="9144000" cy="137162"/>
+            <a:off x="0" y="-2"/>
+            <a:ext cx="9144000" cy="137164"/>
           </a:xfrm>
           <a:prstGeom prst="rect">
             <a:avLst/>
@@ -4634,7 +4945,7 @@
           </a:effectLst>
         </p:spPr>
         <p:txBody>
-          <a:bodyPr lIns="45719" rIns="45719" anchor="ctr"/>
+          <a:bodyPr lIns="45718" tIns="45718" rIns="45718" bIns="45718" anchor="ctr"/>
           <a:lstStyle/>
           <a:p>
             <a:pPr algn="ctr">
@@ -4642,6 +4953,10 @@
                 <a:solidFill>
                   <a:srgbClr val="FFFFFF"/>
                 </a:solidFill>
+                <a:latin typeface="+mn-lt"/>
+                <a:ea typeface="+mn-ea"/>
+                <a:cs typeface="+mn-cs"/>
+                <a:sym typeface="Calibri"/>
               </a:defRPr>
             </a:pPr>
           </a:p>
@@ -4689,6 +5004,10 @@
           </p:nvPr>
         </p:nvSpPr>
         <p:spPr>
+          <a:xfrm>
+            <a:off x="457200" y="274638"/>
+            <a:ext cx="8229600" cy="1143001"/>
+          </a:xfrm>
           <a:prstGeom prst="rect">
             <a:avLst/>
           </a:prstGeom>
@@ -4696,8 +5015,8 @@
         <p:txBody>
           <a:bodyPr/>
           <a:lstStyle>
-            <a:lvl1pPr defTabSz="393192">
-              <a:defRPr sz="3784"/>
+            <a:lvl1pPr defTabSz="393191">
+              <a:defRPr sz="3700"/>
             </a:lvl1pPr>
           </a:lstStyle>
           <a:p>
@@ -4729,66 +5048,77 @@
           <a:bodyPr/>
           <a:lstStyle/>
           <a:p>
-            <a:pPr marL="305180" indent="-305180" defTabSz="406908">
-              <a:spcBef>
-                <a:spcPts val="600"/>
-              </a:spcBef>
-              <a:defRPr sz="2848"/>
-            </a:pPr>
-            <a:r>
-              <a:t>The Danger of Long-Term Memory in Enterprise RAG:</a:t>
-            </a:r>
-          </a:p>
-          <a:p>
-            <a:pPr lvl="1" marL="661225" indent="-254317" defTabSz="406908">
+            <a:pPr marL="296024" indent="-296024" defTabSz="394700">
               <a:spcBef>
                 <a:spcPts val="500"/>
               </a:spcBef>
-              <a:defRPr sz="2492"/>
+              <a:defRPr sz="2716"/>
+            </a:pPr>
+            <a:r>
+              <a:t>The Danger of Long-Term Memory in  RAG:</a:t>
+            </a:r>
+          </a:p>
+          <a:p>
+            <a:pPr lvl="1" marL="641388" indent="-246687" defTabSz="394700">
+              <a:spcBef>
+                <a:spcPts val="400"/>
+              </a:spcBef>
+              <a:defRPr sz="2328"/>
             </a:pPr>
             <a:r>
               <a:t>Passing full chat history back into the LLM inevitably causes 'attention drift'.</a:t>
             </a:r>
           </a:p>
           <a:p>
-            <a:pPr lvl="1" marL="661225" indent="-254317" defTabSz="406908">
+            <a:pPr lvl="1" marL="641388" indent="-246687" defTabSz="394700">
+              <a:spcBef>
+                <a:spcPts val="400"/>
+              </a:spcBef>
+              <a:defRPr sz="2328"/>
+            </a:pPr>
+            <a:r>
+              <a:t>The LLM begins confusing constraints from 10 messages ago with the current query, destroying accuracy.</a:t>
+            </a:r>
+          </a:p>
+          <a:p>
+            <a:pPr marL="296024" indent="-296024" defTabSz="394700">
               <a:spcBef>
                 <a:spcPts val="500"/>
               </a:spcBef>
-              <a:defRPr sz="2492"/>
-            </a:pPr>
-            <a:r>
-              <a:t>The LLM begins confusing constraints from 10 messages ago with the current query, destroying accuracy.</a:t>
-            </a:r>
-          </a:p>
-          <a:p>
-            <a:pPr marL="305180" indent="-305180" defTabSz="406908">
-              <a:spcBef>
-                <a:spcPts val="600"/>
-              </a:spcBef>
-              <a:defRPr sz="2848"/>
-            </a:pPr>
-            <a:r>
-              <a:t>Our Deliberate Solution: Strict Stateless Execution</a:t>
-            </a:r>
-          </a:p>
-          <a:p>
-            <a:pPr lvl="1" marL="661225" indent="-254317" defTabSz="406908">
-              <a:spcBef>
-                <a:spcPts val="500"/>
-              </a:spcBef>
-              <a:defRPr sz="2492"/>
+              <a:defRPr sz="2716"/>
+            </a:pPr>
+            <a:r>
+              <a:t>Solution: One turn based Chatbot.</a:t>
+            </a:r>
+          </a:p>
+          <a:p>
+            <a:pPr lvl="1" marL="641388" indent="-246687" defTabSz="394700">
+              <a:spcBef>
+                <a:spcPts val="400"/>
+              </a:spcBef>
+              <a:defRPr sz="2328"/>
             </a:pPr>
             <a:r>
               <a:t>Every single query is treated as a fresh, strict database lookup.</a:t>
             </a:r>
           </a:p>
           <a:p>
-            <a:pPr lvl="1" marL="661225" indent="-254317" defTabSz="406908">
-              <a:spcBef>
-                <a:spcPts val="500"/>
-              </a:spcBef>
-              <a:defRPr sz="2492"/>
+            <a:pPr lvl="1" marL="641388" indent="-246687" defTabSz="394700">
+              <a:spcBef>
+                <a:spcPts val="400"/>
+              </a:spcBef>
+              <a:defRPr sz="2328"/>
+            </a:pPr>
+            <a:r>
+              <a:t>The User can have one turn to clarify the ambiguity, the agent will ask the question to clarify.</a:t>
+            </a:r>
+          </a:p>
+          <a:p>
+            <a:pPr lvl="1" marL="641388" indent="-246687" defTabSz="394700">
+              <a:spcBef>
+                <a:spcPts val="400"/>
+              </a:spcBef>
+              <a:defRPr sz="2328"/>
             </a:pPr>
             <a:r>
               <a:t>The 100th question in a session is mathematically guaranteed to be as precise and grounded as the 1st.</a:t>
@@ -4804,8 +5134,8 @@
         </p:nvSpPr>
         <p:spPr>
           <a:xfrm>
-            <a:off x="0" y="-1"/>
-            <a:ext cx="9144000" cy="137162"/>
+            <a:off x="0" y="-2"/>
+            <a:ext cx="9144000" cy="137164"/>
           </a:xfrm>
           <a:prstGeom prst="rect">
             <a:avLst/>
@@ -4827,7 +5157,7 @@
           </a:effectLst>
         </p:spPr>
         <p:txBody>
-          <a:bodyPr lIns="45719" rIns="45719" anchor="ctr"/>
+          <a:bodyPr lIns="45718" tIns="45718" rIns="45718" bIns="45718" anchor="ctr"/>
           <a:lstStyle/>
           <a:p>
             <a:pPr algn="ctr">
@@ -4835,6 +5165,10 @@
                 <a:solidFill>
                   <a:srgbClr val="FFFFFF"/>
                 </a:solidFill>
+                <a:latin typeface="+mn-lt"/>
+                <a:ea typeface="+mn-ea"/>
+                <a:cs typeface="+mn-cs"/>
+                <a:sym typeface="Calibri"/>
               </a:defRPr>
             </a:pPr>
           </a:p>
@@ -4882,17 +5216,25 @@
           </p:nvPr>
         </p:nvSpPr>
         <p:spPr>
+          <a:xfrm>
+            <a:off x="457200" y="274638"/>
+            <a:ext cx="8229600" cy="1143002"/>
+          </a:xfrm>
           <a:prstGeom prst="rect">
             <a:avLst/>
           </a:prstGeom>
         </p:spPr>
         <p:txBody>
           <a:bodyPr/>
-          <a:lstStyle/>
+          <a:lstStyle>
+            <a:lvl1pPr defTabSz="393191">
+              <a:defRPr sz="3700"/>
+            </a:lvl1pPr>
+          </a:lstStyle>
           <a:p>
             <a:pPr/>
             <a:r>
-              <a:t>Latency &amp; Execution Controls</a:t>
+              <a:t>Explainability.</a:t>
             </a:r>
           </a:p>
         </p:txBody>
@@ -4918,108 +5260,67 @@
           <a:bodyPr/>
           <a:lstStyle/>
           <a:p>
-            <a:pPr marL="277749" indent="-277749" defTabSz="370331">
+            <a:pPr marL="305179" indent="-305179" defTabSz="406908">
               <a:spcBef>
                 <a:spcPts val="600"/>
               </a:spcBef>
-              <a:defRPr sz="2592"/>
-            </a:pPr>
-            <a:r>
-              <a:t>Target Latency SLA (~1.6s End-to-End):</a:t>
-            </a:r>
-          </a:p>
-          <a:p>
-            <a:pPr lvl="1" marL="601789" indent="-231457" defTabSz="370331">
+              <a:defRPr sz="2800"/>
+            </a:pPr>
+            <a:r>
+              <a:t>Reasoning:</a:t>
+            </a:r>
+          </a:p>
+          <a:p>
+            <a:pPr lvl="1" marL="661224" indent="-254316" defTabSz="406908">
               <a:spcBef>
                 <a:spcPts val="500"/>
               </a:spcBef>
-              <a:defRPr sz="2268"/>
-            </a:pPr>
-            <a:r>
-              <a:t>Plan (Small LLM): ~200ms</a:t>
-            </a:r>
-          </a:p>
-          <a:p>
-            <a:pPr lvl="1" marL="601789" indent="-231457" defTabSz="370331">
+              <a:defRPr sz="2400"/>
+            </a:pPr>
+            <a:r>
+              <a:t>The agent always has the reasoning so the user can understand the rationale behind the generated answer.</a:t>
+            </a:r>
+          </a:p>
+          <a:p>
+            <a:pPr lvl="1" marL="661224" indent="-254316" defTabSz="406908">
               <a:spcBef>
                 <a:spcPts val="500"/>
               </a:spcBef>
-              <a:defRPr sz="2268"/>
-            </a:pPr>
-            <a:r>
-              <a:t>Clarify Gate (DuckDB): &lt;5ms (Fail-fast validation)</a:t>
-            </a:r>
-          </a:p>
-          <a:p>
-            <a:pPr lvl="1" marL="601789" indent="-231457" defTabSz="370331">
+              <a:defRPr sz="2400"/>
+            </a:pPr>
+          </a:p>
+          <a:p>
+            <a:pPr marL="261582" indent="-261582" defTabSz="406908">
+              <a:spcBef>
+                <a:spcPts val="600"/>
+              </a:spcBef>
+              <a:defRPr sz="2800"/>
+            </a:pPr>
+            <a:r>
+              <a:rPr sz="2400"/>
+              <a:t>Citation:</a:t>
+            </a:r>
+          </a:p>
+          <a:p>
+            <a:pPr lvl="1" marL="661224" indent="-254316" defTabSz="406908">
               <a:spcBef>
                 <a:spcPts val="500"/>
               </a:spcBef>
-              <a:defRPr sz="2268"/>
-            </a:pPr>
-            <a:r>
-              <a:t>Hybrid Union + Cross-Encoder: ~150ms</a:t>
-            </a:r>
-          </a:p>
-          <a:p>
-            <a:pPr lvl="1" marL="601789" indent="-231457" defTabSz="370331">
+              <a:defRPr sz="2400"/>
+            </a:pPr>
+            <a:r>
+              <a:t>Every single answer is backed by citations directly from the source.</a:t>
+            </a:r>
+          </a:p>
+          <a:p>
+            <a:pPr lvl="1" marL="661224" indent="-254316" defTabSz="406908">
               <a:spcBef>
                 <a:spcPts val="500"/>
               </a:spcBef>
-              <a:defRPr sz="2268"/>
-            </a:pPr>
-            <a:r>
-              <a:t>Answer Synthesis: ~1.2s (Streaming)</a:t>
-            </a:r>
-          </a:p>
-          <a:p>
-            <a:pPr marL="277749" indent="-277749" defTabSz="370331">
-              <a:spcBef>
-                <a:spcPts val="600"/>
-              </a:spcBef>
-              <a:defRPr sz="2592"/>
-            </a:pPr>
-            <a:r>
-              <a:t>Strict Retry Caps:</a:t>
-            </a:r>
-          </a:p>
-          <a:p>
-            <a:pPr lvl="1" marL="601789" indent="-231457" defTabSz="370331">
-              <a:spcBef>
-                <a:spcPts val="500"/>
-              </a:spcBef>
-              <a:defRPr sz="2268"/>
-            </a:pPr>
-            <a:r>
-              <a:t>O(1) loop depth limit (max_iterations = 2). Graph explicitly prevents infinite execution.</a:t>
-            </a:r>
-          </a:p>
-          <a:p>
-            <a:pPr marL="277749" indent="-277749" defTabSz="370331">
-              <a:spcBef>
-                <a:spcPts val="600"/>
-              </a:spcBef>
-              <a:defRPr sz="2592"/>
-            </a:pPr>
-            <a:r>
-              <a:t>Token Budget Management:</a:t>
-            </a:r>
-          </a:p>
-          <a:p>
-            <a:pPr lvl="1" marL="601789" indent="-231457" defTabSz="370331">
-              <a:spcBef>
-                <a:spcPts val="500"/>
-              </a:spcBef>
-              <a:defRPr sz="2268"/>
-            </a:pPr>
-            <a:r>
-              <a:t>Cross-Encoder strictly caps LLM input context to &lt;2,000 tokens.</a:t>
-            </a:r>
-          </a:p>
-          <a:p>
-            <a:pPr/>
-            <a:r>
-              <a:t>Dynamic Search Depth: k expands on retries to prevent placebo loops.</a:t>
+              <a:defRPr sz="2400"/>
+            </a:pPr>
+            <a:r>
+              <a:t>Improves explainability of the answers.</a:t>
             </a:r>
           </a:p>
         </p:txBody>
@@ -5032,8 +5333,8 @@
         </p:nvSpPr>
         <p:spPr>
           <a:xfrm>
-            <a:off x="0" y="-1"/>
-            <a:ext cx="9144000" cy="137162"/>
+            <a:off x="0" y="-2"/>
+            <a:ext cx="9144000" cy="137164"/>
           </a:xfrm>
           <a:prstGeom prst="rect">
             <a:avLst/>
@@ -5055,7 +5356,7 @@
           </a:effectLst>
         </p:spPr>
         <p:txBody>
-          <a:bodyPr lIns="45719" rIns="45719" anchor="ctr"/>
+          <a:bodyPr lIns="45718" tIns="45718" rIns="45718" bIns="45718" anchor="ctr"/>
           <a:lstStyle/>
           <a:p>
             <a:pPr algn="ctr">
@@ -5063,6 +5364,10 @@
                 <a:solidFill>
                   <a:srgbClr val="FFFFFF"/>
                 </a:solidFill>
+                <a:latin typeface="+mn-lt"/>
+                <a:ea typeface="+mn-ea"/>
+                <a:cs typeface="+mn-cs"/>
+                <a:sym typeface="Calibri"/>
               </a:defRPr>
             </a:pPr>
           </a:p>
@@ -5110,6 +5415,10 @@
           </p:nvPr>
         </p:nvSpPr>
         <p:spPr>
+          <a:xfrm>
+            <a:off x="457200" y="274638"/>
+            <a:ext cx="8229600" cy="1143001"/>
+          </a:xfrm>
           <a:prstGeom prst="rect">
             <a:avLst/>
           </a:prstGeom>
@@ -5120,7 +5429,7 @@
           <a:p>
             <a:pPr/>
             <a:r>
-              <a:t>Model Risk Management (MRM)</a:t>
+              <a:t>Latency &amp; Execution Controls</a:t>
             </a:r>
           </a:p>
         </p:txBody>
@@ -5135,8 +5444,8 @@
         </p:nvSpPr>
         <p:spPr>
           <a:xfrm>
-            <a:off x="457200" y="1600200"/>
-            <a:ext cx="8229600" cy="4525963"/>
+            <a:off x="457200" y="1550353"/>
+            <a:ext cx="8229601" cy="4525964"/>
           </a:xfrm>
           <a:prstGeom prst="rect">
             <a:avLst/>
@@ -5146,60 +5455,113 @@
           <a:bodyPr/>
           <a:lstStyle/>
           <a:p>
-            <a:pPr marL="332613" indent="-332613" defTabSz="443484">
-              <a:defRPr sz="3104"/>
-            </a:pPr>
-            <a:r>
-              <a:t>100% Traceability</a:t>
-            </a:r>
-          </a:p>
-          <a:p>
-            <a:pPr lvl="1" marL="720661" indent="-277177" defTabSz="443484">
+            <a:pPr marL="241641" indent="-241641" defTabSz="322187">
+              <a:spcBef>
+                <a:spcPts val="500"/>
+              </a:spcBef>
+              <a:defRPr sz="2175"/>
+            </a:pPr>
+            <a:r>
+              <a:t>Target Latency SLA (~1.6s End-to-End):</a:t>
+            </a:r>
+          </a:p>
+          <a:p>
+            <a:pPr lvl="1" marL="523556" indent="-201367" defTabSz="322187">
+              <a:spcBef>
+                <a:spcPts val="400"/>
+              </a:spcBef>
+              <a:defRPr sz="1914"/>
+            </a:pPr>
+            <a:r>
+              <a:t>Plan (Small LLM): ~200ms</a:t>
+            </a:r>
+          </a:p>
+          <a:p>
+            <a:pPr lvl="1" marL="523556" indent="-201367" defTabSz="322187">
+              <a:spcBef>
+                <a:spcPts val="400"/>
+              </a:spcBef>
+              <a:defRPr sz="1914"/>
+            </a:pPr>
+            <a:r>
+              <a:t>Clarify Gate (DuckDB): &lt;5ms (Fail-fast validation)</a:t>
+            </a:r>
+          </a:p>
+          <a:p>
+            <a:pPr lvl="1" marL="523556" indent="-201367" defTabSz="322187">
+              <a:spcBef>
+                <a:spcPts val="400"/>
+              </a:spcBef>
+              <a:defRPr sz="1914"/>
+            </a:pPr>
+            <a:r>
+              <a:t>Hybrid Union + Cross-Encoder: ~150ms</a:t>
+            </a:r>
+          </a:p>
+          <a:p>
+            <a:pPr lvl="1" marL="523556" indent="-201367" defTabSz="322187">
+              <a:spcBef>
+                <a:spcPts val="400"/>
+              </a:spcBef>
+              <a:defRPr sz="1914"/>
+            </a:pPr>
+            <a:r>
+              <a:t>Answer Synthesis: ~1.2s (Streaming)</a:t>
+            </a:r>
+          </a:p>
+          <a:p>
+            <a:pPr marL="241641" indent="-241641" defTabSz="322187">
+              <a:spcBef>
+                <a:spcPts val="500"/>
+              </a:spcBef>
+              <a:defRPr sz="2175"/>
+            </a:pPr>
+            <a:r>
+              <a:t>Strict Retry Caps:</a:t>
+            </a:r>
+          </a:p>
+          <a:p>
+            <a:pPr lvl="1" marL="523556" indent="-201367" defTabSz="322187">
+              <a:spcBef>
+                <a:spcPts val="400"/>
+              </a:spcBef>
+              <a:defRPr sz="1914"/>
+            </a:pPr>
+            <a:r>
+              <a:t>O(1) loop depth limit (max_iterations = 2). Graph explicitly prevents infinite execution.</a:t>
+            </a:r>
+          </a:p>
+          <a:p>
+            <a:pPr marL="241641" indent="-241641" defTabSz="322187">
+              <a:spcBef>
+                <a:spcPts val="500"/>
+              </a:spcBef>
+              <a:defRPr sz="2175"/>
+            </a:pPr>
+            <a:r>
+              <a:t>Token Budget Management:</a:t>
+            </a:r>
+          </a:p>
+          <a:p>
+            <a:pPr lvl="1" marL="523556" indent="-201367" defTabSz="322187">
+              <a:spcBef>
+                <a:spcPts val="400"/>
+              </a:spcBef>
+              <a:defRPr sz="1914"/>
+            </a:pPr>
+            <a:r>
+              <a:t>Cross-Encoder strictly caps LLM input context to &lt;2,000 tokens.</a:t>
+            </a:r>
+          </a:p>
+          <a:p>
+            <a:pPr marL="298322" indent="-298322" defTabSz="397763">
               <a:spcBef>
                 <a:spcPts val="600"/>
               </a:spcBef>
-              <a:defRPr sz="2716"/>
-            </a:pPr>
-            <a:r>
-              <a:t>The Pydantic state object records every SQL match, candidate score, and node transition.</a:t>
-            </a:r>
-          </a:p>
-          <a:p>
-            <a:pPr marL="332613" indent="-332613" defTabSz="443484">
-              <a:defRPr sz="3104"/>
-            </a:pPr>
-            <a:r>
-              <a:t>Audit-Ready Logs</a:t>
-            </a:r>
-          </a:p>
-          <a:p>
-            <a:pPr lvl="1" marL="720661" indent="-277177" defTabSz="443484">
-              <a:spcBef>
-                <a:spcPts val="600"/>
-              </a:spcBef>
-              <a:defRPr sz="2716"/>
-            </a:pPr>
-            <a:r>
-              <a:t>Execution traces can be piped directly to internal telemetry platforms for MRM compliance.</a:t>
-            </a:r>
-          </a:p>
-          <a:p>
-            <a:pPr marL="332613" indent="-332613" defTabSz="443484">
-              <a:defRPr sz="3104"/>
-            </a:pPr>
-            <a:r>
-              <a:t>Deterministic Citations</a:t>
-            </a:r>
-          </a:p>
-          <a:p>
-            <a:pPr lvl="1" marL="720661" indent="-277177" defTabSz="443484">
-              <a:spcBef>
-                <a:spcPts val="600"/>
-              </a:spcBef>
-              <a:defRPr sz="2716"/>
-            </a:pPr>
-            <a:r>
-              <a:t>Every generated claim is hard-bound to a specific chunk_id and SEC canonical source URL.</a:t>
+              <a:defRPr sz="2784"/>
+            </a:pPr>
+            <a:r>
+              <a:t>Dynamic Search Depth: k expands on retries to prevent placebo loops.</a:t>
             </a:r>
           </a:p>
         </p:txBody>
@@ -5212,8 +5574,8 @@
         </p:nvSpPr>
         <p:spPr>
           <a:xfrm>
-            <a:off x="0" y="-1"/>
-            <a:ext cx="9144000" cy="137162"/>
+            <a:off x="0" y="-2"/>
+            <a:ext cx="9144000" cy="137164"/>
           </a:xfrm>
           <a:prstGeom prst="rect">
             <a:avLst/>
@@ -5235,7 +5597,7 @@
           </a:effectLst>
         </p:spPr>
         <p:txBody>
-          <a:bodyPr lIns="45719" rIns="45719" anchor="ctr"/>
+          <a:bodyPr lIns="45718" tIns="45718" rIns="45718" bIns="45718" anchor="ctr"/>
           <a:lstStyle/>
           <a:p>
             <a:pPr algn="ctr">
@@ -5243,6 +5605,10 @@
                 <a:solidFill>
                   <a:srgbClr val="FFFFFF"/>
                 </a:solidFill>
+                <a:latin typeface="+mn-lt"/>
+                <a:ea typeface="+mn-ea"/>
+                <a:cs typeface="+mn-cs"/>
+                <a:sym typeface="Calibri"/>
               </a:defRPr>
             </a:pPr>
           </a:p>
@@ -5300,14 +5666,14 @@
     </a:clrScheme>
     <a:fontScheme name="Office Theme">
       <a:majorFont>
+        <a:latin typeface="Helvetica"/>
+        <a:ea typeface="Helvetica"/>
+        <a:cs typeface="Helvetica"/>
+      </a:majorFont>
+      <a:minorFont>
         <a:latin typeface="Calibri"/>
         <a:ea typeface="Calibri"/>
         <a:cs typeface="Calibri"/>
-      </a:majorFont>
-      <a:minorFont>
-        <a:latin typeface="Helvetica"/>
-        <a:ea typeface="Helvetica"/>
-        <a:cs typeface="Helvetica"/>
       </a:minorFont>
     </a:fontScheme>
     <a:fmtScheme name="Office Theme">
@@ -5402,9 +5768,9 @@
         </a:effectStyle>
         <a:effectStyle>
           <a:effectLst>
-            <a:outerShdw sx="100000" sy="100000" kx="0" ky="0" algn="b" rotWithShape="0" blurRad="38100" dist="20000" dir="5400000">
+            <a:outerShdw sx="100000" sy="100000" kx="0" ky="0" algn="b" rotWithShape="0" blurRad="38100" dist="23000" dir="5400000">
               <a:srgbClr val="000000">
-                <a:alpha val="38000"/>
+                <a:alpha val="35000"/>
               </a:srgbClr>
             </a:outerShdw>
           </a:effectLst>
@@ -5484,7 +5850,7 @@
         </a:effectLst>
         <a:sp3d/>
       </a:spPr>
-      <a:bodyPr rot="0" spcFirstLastPara="1" vertOverflow="overflow" horzOverflow="overflow" vert="horz" wrap="square" lIns="45719" tIns="45719" rIns="45719" bIns="45719" numCol="1" spcCol="38100" rtlCol="0" anchor="ctr" upright="0">
+      <a:bodyPr rot="0" spcFirstLastPara="1" vertOverflow="overflow" horzOverflow="overflow" vert="horz" wrap="square" lIns="45718" tIns="45718" rIns="45718" bIns="45718" numCol="1" spcCol="38100" rtlCol="0" anchor="ctr" upright="0">
         <a:spAutoFit/>
       </a:bodyPr>
       <a:lstStyle>
@@ -5515,7 +5881,7 @@
             <a:latin typeface="+mj-lt"/>
             <a:ea typeface="+mj-ea"/>
             <a:cs typeface="+mj-cs"/>
-            <a:sym typeface="Calibri"/>
+            <a:sym typeface="Helvetica"/>
           </a:defRPr>
         </a:defPPr>
         <a:lvl1pPr marL="0" marR="0" indent="0" algn="l" defTabSz="914400" rtl="0" fontAlgn="auto" latinLnBrk="1" hangingPunct="0">
@@ -5771,9 +6137,9 @@
           <a:round/>
         </a:ln>
         <a:effectLst>
-          <a:outerShdw sx="100000" sy="100000" kx="0" ky="0" algn="b" rotWithShape="0" blurRad="38100" dist="20000" dir="5400000">
+          <a:outerShdw sx="100000" sy="100000" kx="0" ky="0" algn="b" rotWithShape="0" blurRad="38100" dist="23000" dir="5400000">
             <a:srgbClr val="000000">
-              <a:alpha val="38000"/>
+              <a:alpha val="35000"/>
             </a:srgbClr>
           </a:outerShdw>
         </a:effectLst>
@@ -6061,7 +6427,7 @@
         <a:effectLst/>
         <a:sp3d/>
       </a:spPr>
-      <a:bodyPr rot="0" spcFirstLastPara="1" vertOverflow="overflow" horzOverflow="overflow" vert="horz" wrap="square" lIns="45719" tIns="45719" rIns="45719" bIns="45719" numCol="1" spcCol="38100" rtlCol="0" anchor="t" upright="0">
+      <a:bodyPr rot="0" spcFirstLastPara="1" vertOverflow="overflow" horzOverflow="overflow" vert="horz" wrap="square" lIns="45718" tIns="45718" rIns="45718" bIns="45718" numCol="1" spcCol="38100" rtlCol="0" anchor="t" upright="0">
         <a:spAutoFit/>
       </a:bodyPr>
       <a:lstStyle>
@@ -6092,7 +6458,7 @@
             <a:latin typeface="+mj-lt"/>
             <a:ea typeface="+mj-ea"/>
             <a:cs typeface="+mj-cs"/>
-            <a:sym typeface="Calibri"/>
+            <a:sym typeface="Helvetica"/>
           </a:defRPr>
         </a:defPPr>
         <a:lvl1pPr marL="0" marR="0" indent="0" algn="l" defTabSz="914400" rtl="0" fontAlgn="auto" latinLnBrk="1" hangingPunct="0">
@@ -6384,14 +6750,14 @@
     </a:clrScheme>
     <a:fontScheme name="Office Theme">
       <a:majorFont>
+        <a:latin typeface="Helvetica"/>
+        <a:ea typeface="Helvetica"/>
+        <a:cs typeface="Helvetica"/>
+      </a:majorFont>
+      <a:minorFont>
         <a:latin typeface="Calibri"/>
         <a:ea typeface="Calibri"/>
         <a:cs typeface="Calibri"/>
-      </a:majorFont>
-      <a:minorFont>
-        <a:latin typeface="Helvetica"/>
-        <a:ea typeface="Helvetica"/>
-        <a:cs typeface="Helvetica"/>
       </a:minorFont>
     </a:fontScheme>
     <a:fmtScheme name="Office Theme">
@@ -6486,9 +6852,9 @@
         </a:effectStyle>
         <a:effectStyle>
           <a:effectLst>
-            <a:outerShdw sx="100000" sy="100000" kx="0" ky="0" algn="b" rotWithShape="0" blurRad="38100" dist="20000" dir="5400000">
+            <a:outerShdw sx="100000" sy="100000" kx="0" ky="0" algn="b" rotWithShape="0" blurRad="38100" dist="23000" dir="5400000">
               <a:srgbClr val="000000">
-                <a:alpha val="38000"/>
+                <a:alpha val="35000"/>
               </a:srgbClr>
             </a:outerShdw>
           </a:effectLst>
@@ -6568,7 +6934,7 @@
         </a:effectLst>
         <a:sp3d/>
       </a:spPr>
-      <a:bodyPr rot="0" spcFirstLastPara="1" vertOverflow="overflow" horzOverflow="overflow" vert="horz" wrap="square" lIns="45719" tIns="45719" rIns="45719" bIns="45719" numCol="1" spcCol="38100" rtlCol="0" anchor="ctr" upright="0">
+      <a:bodyPr rot="0" spcFirstLastPara="1" vertOverflow="overflow" horzOverflow="overflow" vert="horz" wrap="square" lIns="45718" tIns="45718" rIns="45718" bIns="45718" numCol="1" spcCol="38100" rtlCol="0" anchor="ctr" upright="0">
         <a:spAutoFit/>
       </a:bodyPr>
       <a:lstStyle>
@@ -6599,7 +6965,7 @@
             <a:latin typeface="+mj-lt"/>
             <a:ea typeface="+mj-ea"/>
             <a:cs typeface="+mj-cs"/>
-            <a:sym typeface="Calibri"/>
+            <a:sym typeface="Helvetica"/>
           </a:defRPr>
         </a:defPPr>
         <a:lvl1pPr marL="0" marR="0" indent="0" algn="l" defTabSz="914400" rtl="0" fontAlgn="auto" latinLnBrk="1" hangingPunct="0">
@@ -6855,9 +7221,9 @@
           <a:round/>
         </a:ln>
         <a:effectLst>
-          <a:outerShdw sx="100000" sy="100000" kx="0" ky="0" algn="b" rotWithShape="0" blurRad="38100" dist="20000" dir="5400000">
+          <a:outerShdw sx="100000" sy="100000" kx="0" ky="0" algn="b" rotWithShape="0" blurRad="38100" dist="23000" dir="5400000">
             <a:srgbClr val="000000">
-              <a:alpha val="38000"/>
+              <a:alpha val="35000"/>
             </a:srgbClr>
           </a:outerShdw>
         </a:effectLst>
@@ -7145,7 +7511,7 @@
         <a:effectLst/>
         <a:sp3d/>
       </a:spPr>
-      <a:bodyPr rot="0" spcFirstLastPara="1" vertOverflow="overflow" horzOverflow="overflow" vert="horz" wrap="square" lIns="45719" tIns="45719" rIns="45719" bIns="45719" numCol="1" spcCol="38100" rtlCol="0" anchor="t" upright="0">
+      <a:bodyPr rot="0" spcFirstLastPara="1" vertOverflow="overflow" horzOverflow="overflow" vert="horz" wrap="square" lIns="45718" tIns="45718" rIns="45718" bIns="45718" numCol="1" spcCol="38100" rtlCol="0" anchor="t" upright="0">
         <a:spAutoFit/>
       </a:bodyPr>
       <a:lstStyle>
@@ -7176,7 +7542,7 @@
             <a:latin typeface="+mj-lt"/>
             <a:ea typeface="+mj-ea"/>
             <a:cs typeface="+mj-cs"/>
-            <a:sym typeface="Calibri"/>
+            <a:sym typeface="Helvetica"/>
           </a:defRPr>
         </a:defPPr>
         <a:lvl1pPr marL="0" marR="0" indent="0" algn="l" defTabSz="914400" rtl="0" fontAlgn="auto" latinLnBrk="1" hangingPunct="0">

</xml_diff>